<commit_message>
feat(build_slides): glass teaching decks put content on a frosted sheet; CNS decks rebuilt
- GlassDeck: one frosted sheet behind the content band; explanations with an accent bar;
  figures on a white card with a soft shadow; the feature-callout text on its own sheet.
- CNS practical: 9 decks rebuilt; lint unchanged.

Co-Authored-By: Claude Opus 5.5 <noreply@anthropic.com>
</commit_message>
<xml_diff>
--- a/projects/cns-pharmacology-practical/slides/ch01-alzheimers-disease.pptx
+++ b/projects/cns-pharmacology-practical/slides/ch01-alzheimers-disease.pptx
@@ -5961,9 +5961,113 @@
           </a:prstGeom>
         </p:spPr>
       </p:pic>
+      <p:sp>
+        <p:nvSpPr>
+          <p:cNvPr id="11" name="Rounded Rectangle 10"/>
+          <p:cNvSpPr/>
+          <p:nvPr/>
+        </p:nvSpPr>
+        <p:spPr>
+          <a:xfrm>
+            <a:off x="411479" y="1444752"/>
+            <a:ext cx="11368735" cy="4800600"/>
+          </a:xfrm>
+          <a:prstGeom prst="roundRect">
+            <a:avLst>
+              <a:gd name="adj" fmla="val 4000"/>
+            </a:avLst>
+          </a:prstGeom>
+          <a:solidFill>
+            <a:srgbClr val="FFFFFF">
+              <a:alpha val="84000"/>
+            </a:srgbClr>
+          </a:solidFill>
+          <a:ln w="19050">
+            <a:solidFill>
+              <a:srgbClr val="FFFFFF"/>
+            </a:solidFill>
+          </a:ln>
+          <a:effectLst>
+            <a:outerShdw blurRad="203200" dist="50800" dir="5400000" algn="t" rotWithShape="0">
+              <a:srgbClr val="1A2340">
+                <a:alpha val="20000"/>
+              </a:srgbClr>
+            </a:outerShdw>
+          </a:effectLst>
+        </p:spPr>
+        <p:style>
+          <a:lnRef idx="1">
+            <a:schemeClr val="accent1"/>
+          </a:lnRef>
+          <a:fillRef idx="3">
+            <a:schemeClr val="accent1"/>
+          </a:fillRef>
+          <a:effectRef idx="2">
+            <a:schemeClr val="accent1"/>
+          </a:effectRef>
+          <a:fontRef idx="minor">
+            <a:schemeClr val="lt1"/>
+          </a:fontRef>
+        </p:style>
+        <p:txBody>
+          <a:bodyPr rtlCol="0" anchor="ctr"/>
+          <a:lstStyle/>
+          <a:p>
+            <a:pPr algn="ctr"/>
+          </a:p>
+        </p:txBody>
+      </p:sp>
+      <p:sp>
+        <p:nvSpPr>
+          <p:cNvPr id="12" name="Rounded Rectangle 11"/>
+          <p:cNvSpPr/>
+          <p:nvPr/>
+        </p:nvSpPr>
+        <p:spPr>
+          <a:xfrm>
+            <a:off x="731519" y="1508760"/>
+            <a:ext cx="10728655" cy="32004"/>
+          </a:xfrm>
+          <a:prstGeom prst="roundRect">
+            <a:avLst>
+              <a:gd name="adj" fmla="val 50000"/>
+            </a:avLst>
+          </a:prstGeom>
+          <a:solidFill>
+            <a:srgbClr val="FFFFFF">
+              <a:alpha val="85000"/>
+            </a:srgbClr>
+          </a:solidFill>
+          <a:ln>
+            <a:noFill/>
+          </a:ln>
+          <a:effectLst/>
+        </p:spPr>
+        <p:style>
+          <a:lnRef idx="1">
+            <a:schemeClr val="accent1"/>
+          </a:lnRef>
+          <a:fillRef idx="3">
+            <a:schemeClr val="accent1"/>
+          </a:fillRef>
+          <a:effectRef idx="2">
+            <a:schemeClr val="accent1"/>
+          </a:effectRef>
+          <a:fontRef idx="minor">
+            <a:schemeClr val="lt1"/>
+          </a:fontRef>
+        </p:style>
+        <p:txBody>
+          <a:bodyPr rtlCol="0" anchor="ctr"/>
+          <a:lstStyle/>
+          <a:p>
+            <a:pPr algn="ctr"/>
+          </a:p>
+        </p:txBody>
+      </p:sp>
       <p:graphicFrame>
         <p:nvGraphicFramePr>
-          <p:cNvPr id="11" name="Table 10"/>
+          <p:cNvPr id="13" name="Table 12"/>
           <p:cNvGraphicFramePr>
             <a:graphicFrameLocks noGrp="1"/>
           </p:cNvGraphicFramePr>
@@ -6828,6 +6932,110 @@
         </p:nvSpPr>
         <p:spPr>
           <a:xfrm>
+            <a:off x="411479" y="1444752"/>
+            <a:ext cx="11368735" cy="4800600"/>
+          </a:xfrm>
+          <a:prstGeom prst="roundRect">
+            <a:avLst>
+              <a:gd name="adj" fmla="val 4000"/>
+            </a:avLst>
+          </a:prstGeom>
+          <a:solidFill>
+            <a:srgbClr val="FFFFFF">
+              <a:alpha val="84000"/>
+            </a:srgbClr>
+          </a:solidFill>
+          <a:ln w="19050">
+            <a:solidFill>
+              <a:srgbClr val="FFFFFF"/>
+            </a:solidFill>
+          </a:ln>
+          <a:effectLst>
+            <a:outerShdw blurRad="203200" dist="50800" dir="5400000" algn="t" rotWithShape="0">
+              <a:srgbClr val="1A2340">
+                <a:alpha val="20000"/>
+              </a:srgbClr>
+            </a:outerShdw>
+          </a:effectLst>
+        </p:spPr>
+        <p:style>
+          <a:lnRef idx="1">
+            <a:schemeClr val="accent1"/>
+          </a:lnRef>
+          <a:fillRef idx="3">
+            <a:schemeClr val="accent1"/>
+          </a:fillRef>
+          <a:effectRef idx="2">
+            <a:schemeClr val="accent1"/>
+          </a:effectRef>
+          <a:fontRef idx="minor">
+            <a:schemeClr val="lt1"/>
+          </a:fontRef>
+        </p:style>
+        <p:txBody>
+          <a:bodyPr rtlCol="0" anchor="ctr"/>
+          <a:lstStyle/>
+          <a:p>
+            <a:pPr algn="ctr"/>
+          </a:p>
+        </p:txBody>
+      </p:sp>
+      <p:sp>
+        <p:nvSpPr>
+          <p:cNvPr id="12" name="Rounded Rectangle 11"/>
+          <p:cNvSpPr/>
+          <p:nvPr/>
+        </p:nvSpPr>
+        <p:spPr>
+          <a:xfrm>
+            <a:off x="731519" y="1508760"/>
+            <a:ext cx="10728655" cy="32004"/>
+          </a:xfrm>
+          <a:prstGeom prst="roundRect">
+            <a:avLst>
+              <a:gd name="adj" fmla="val 50000"/>
+            </a:avLst>
+          </a:prstGeom>
+          <a:solidFill>
+            <a:srgbClr val="FFFFFF">
+              <a:alpha val="85000"/>
+            </a:srgbClr>
+          </a:solidFill>
+          <a:ln>
+            <a:noFill/>
+          </a:ln>
+          <a:effectLst/>
+        </p:spPr>
+        <p:style>
+          <a:lnRef idx="1">
+            <a:schemeClr val="accent1"/>
+          </a:lnRef>
+          <a:fillRef idx="3">
+            <a:schemeClr val="accent1"/>
+          </a:fillRef>
+          <a:effectRef idx="2">
+            <a:schemeClr val="accent1"/>
+          </a:effectRef>
+          <a:fontRef idx="minor">
+            <a:schemeClr val="lt1"/>
+          </a:fontRef>
+        </p:style>
+        <p:txBody>
+          <a:bodyPr rtlCol="0" anchor="ctr"/>
+          <a:lstStyle/>
+          <a:p>
+            <a:pPr algn="ctr"/>
+          </a:p>
+        </p:txBody>
+      </p:sp>
+      <p:sp>
+        <p:nvSpPr>
+          <p:cNvPr id="13" name="Rounded Rectangle 12"/>
+          <p:cNvSpPr/>
+          <p:nvPr/>
+        </p:nvSpPr>
+        <p:spPr>
+          <a:xfrm>
             <a:off x="1645919" y="2103120"/>
             <a:ext cx="8899855" cy="3157728"/>
           </a:xfrm>
@@ -6878,7 +7086,7 @@
       </p:sp>
       <p:sp>
         <p:nvSpPr>
-          <p:cNvPr id="12" name="Rounded Rectangle 11"/>
+          <p:cNvPr id="14" name="Rounded Rectangle 13"/>
           <p:cNvSpPr/>
           <p:nvPr/>
         </p:nvSpPr>
@@ -6926,7 +7134,7 @@
       </p:sp>
       <p:sp>
         <p:nvSpPr>
-          <p:cNvPr id="13" name="Rounded Rectangle 12"/>
+          <p:cNvPr id="15" name="Rounded Rectangle 14"/>
           <p:cNvSpPr/>
           <p:nvPr/>
         </p:nvSpPr>
@@ -6994,7 +7202,7 @@
       </p:sp>
       <p:sp>
         <p:nvSpPr>
-          <p:cNvPr id="14" name="TextBox 13"/>
+          <p:cNvPr id="16" name="TextBox 15"/>
           <p:cNvSpPr txBox="1"/>
           <p:nvPr/>
         </p:nvSpPr>
@@ -7414,7 +7622,111 @@
       </p:pic>
       <p:sp>
         <p:nvSpPr>
-          <p:cNvPr id="11" name="Oval 10"/>
+          <p:cNvPr id="11" name="Rounded Rectangle 10"/>
+          <p:cNvSpPr/>
+          <p:nvPr/>
+        </p:nvSpPr>
+        <p:spPr>
+          <a:xfrm>
+            <a:off x="411479" y="1444752"/>
+            <a:ext cx="11368735" cy="4800600"/>
+          </a:xfrm>
+          <a:prstGeom prst="roundRect">
+            <a:avLst>
+              <a:gd name="adj" fmla="val 4000"/>
+            </a:avLst>
+          </a:prstGeom>
+          <a:solidFill>
+            <a:srgbClr val="FFFFFF">
+              <a:alpha val="84000"/>
+            </a:srgbClr>
+          </a:solidFill>
+          <a:ln w="19050">
+            <a:solidFill>
+              <a:srgbClr val="FFFFFF"/>
+            </a:solidFill>
+          </a:ln>
+          <a:effectLst>
+            <a:outerShdw blurRad="203200" dist="50800" dir="5400000" algn="t" rotWithShape="0">
+              <a:srgbClr val="1A2340">
+                <a:alpha val="20000"/>
+              </a:srgbClr>
+            </a:outerShdw>
+          </a:effectLst>
+        </p:spPr>
+        <p:style>
+          <a:lnRef idx="1">
+            <a:schemeClr val="accent1"/>
+          </a:lnRef>
+          <a:fillRef idx="3">
+            <a:schemeClr val="accent1"/>
+          </a:fillRef>
+          <a:effectRef idx="2">
+            <a:schemeClr val="accent1"/>
+          </a:effectRef>
+          <a:fontRef idx="minor">
+            <a:schemeClr val="lt1"/>
+          </a:fontRef>
+        </p:style>
+        <p:txBody>
+          <a:bodyPr rtlCol="0" anchor="ctr"/>
+          <a:lstStyle/>
+          <a:p>
+            <a:pPr algn="ctr"/>
+          </a:p>
+        </p:txBody>
+      </p:sp>
+      <p:sp>
+        <p:nvSpPr>
+          <p:cNvPr id="12" name="Rounded Rectangle 11"/>
+          <p:cNvSpPr/>
+          <p:nvPr/>
+        </p:nvSpPr>
+        <p:spPr>
+          <a:xfrm>
+            <a:off x="731519" y="1508760"/>
+            <a:ext cx="10728655" cy="32004"/>
+          </a:xfrm>
+          <a:prstGeom prst="roundRect">
+            <a:avLst>
+              <a:gd name="adj" fmla="val 50000"/>
+            </a:avLst>
+          </a:prstGeom>
+          <a:solidFill>
+            <a:srgbClr val="FFFFFF">
+              <a:alpha val="85000"/>
+            </a:srgbClr>
+          </a:solidFill>
+          <a:ln>
+            <a:noFill/>
+          </a:ln>
+          <a:effectLst/>
+        </p:spPr>
+        <p:style>
+          <a:lnRef idx="1">
+            <a:schemeClr val="accent1"/>
+          </a:lnRef>
+          <a:fillRef idx="3">
+            <a:schemeClr val="accent1"/>
+          </a:fillRef>
+          <a:effectRef idx="2">
+            <a:schemeClr val="accent1"/>
+          </a:effectRef>
+          <a:fontRef idx="minor">
+            <a:schemeClr val="lt1"/>
+          </a:fontRef>
+        </p:style>
+        <p:txBody>
+          <a:bodyPr rtlCol="0" anchor="ctr"/>
+          <a:lstStyle/>
+          <a:p>
+            <a:pPr algn="ctr"/>
+          </a:p>
+        </p:txBody>
+      </p:sp>
+      <p:sp>
+        <p:nvSpPr>
+          <p:cNvPr id="13" name="Oval 12"/>
           <p:cNvSpPr/>
           <p:nvPr/>
         </p:nvSpPr>
@@ -7467,7 +7779,7 @@
       </p:sp>
       <p:sp>
         <p:nvSpPr>
-          <p:cNvPr id="12" name="TextBox 11"/>
+          <p:cNvPr id="14" name="TextBox 13"/>
           <p:cNvSpPr txBox="1"/>
           <p:nvPr/>
         </p:nvSpPr>
@@ -7510,7 +7822,7 @@
       </p:sp>
       <p:sp>
         <p:nvSpPr>
-          <p:cNvPr id="13" name="Oval 12"/>
+          <p:cNvPr id="15" name="Oval 14"/>
           <p:cNvSpPr/>
           <p:nvPr/>
         </p:nvSpPr>
@@ -7563,7 +7875,7 @@
       </p:sp>
       <p:sp>
         <p:nvSpPr>
-          <p:cNvPr id="14" name="TextBox 13"/>
+          <p:cNvPr id="16" name="TextBox 15"/>
           <p:cNvSpPr txBox="1"/>
           <p:nvPr/>
         </p:nvSpPr>
@@ -7606,7 +7918,7 @@
       </p:sp>
       <p:sp>
         <p:nvSpPr>
-          <p:cNvPr id="15" name="Oval 14"/>
+          <p:cNvPr id="17" name="Oval 16"/>
           <p:cNvSpPr/>
           <p:nvPr/>
         </p:nvSpPr>
@@ -7659,7 +7971,7 @@
       </p:sp>
       <p:sp>
         <p:nvSpPr>
-          <p:cNvPr id="16" name="TextBox 15"/>
+          <p:cNvPr id="18" name="TextBox 17"/>
           <p:cNvSpPr txBox="1"/>
           <p:nvPr/>
         </p:nvSpPr>
@@ -7702,7 +8014,7 @@
       </p:sp>
       <p:sp>
         <p:nvSpPr>
-          <p:cNvPr id="17" name="Oval 16"/>
+          <p:cNvPr id="19" name="Oval 18"/>
           <p:cNvSpPr/>
           <p:nvPr/>
         </p:nvSpPr>
@@ -7755,7 +8067,7 @@
       </p:sp>
       <p:sp>
         <p:nvSpPr>
-          <p:cNvPr id="18" name="TextBox 17"/>
+          <p:cNvPr id="20" name="TextBox 19"/>
           <p:cNvSpPr txBox="1"/>
           <p:nvPr/>
         </p:nvSpPr>
@@ -8179,14 +8491,177 @@
       </p:pic>
       <p:sp>
         <p:nvSpPr>
-          <p:cNvPr id="11" name="TextBox 10"/>
+          <p:cNvPr id="11" name="Rounded Rectangle 10"/>
+          <p:cNvSpPr/>
+          <p:nvPr/>
+        </p:nvSpPr>
+        <p:spPr>
+          <a:xfrm>
+            <a:off x="411479" y="1444752"/>
+            <a:ext cx="11368735" cy="4800600"/>
+          </a:xfrm>
+          <a:prstGeom prst="roundRect">
+            <a:avLst>
+              <a:gd name="adj" fmla="val 4000"/>
+            </a:avLst>
+          </a:prstGeom>
+          <a:solidFill>
+            <a:srgbClr val="FFFFFF">
+              <a:alpha val="84000"/>
+            </a:srgbClr>
+          </a:solidFill>
+          <a:ln w="19050">
+            <a:solidFill>
+              <a:srgbClr val="FFFFFF"/>
+            </a:solidFill>
+          </a:ln>
+          <a:effectLst>
+            <a:outerShdw blurRad="203200" dist="50800" dir="5400000" algn="t" rotWithShape="0">
+              <a:srgbClr val="1A2340">
+                <a:alpha val="20000"/>
+              </a:srgbClr>
+            </a:outerShdw>
+          </a:effectLst>
+        </p:spPr>
+        <p:style>
+          <a:lnRef idx="1">
+            <a:schemeClr val="accent1"/>
+          </a:lnRef>
+          <a:fillRef idx="3">
+            <a:schemeClr val="accent1"/>
+          </a:fillRef>
+          <a:effectRef idx="2">
+            <a:schemeClr val="accent1"/>
+          </a:effectRef>
+          <a:fontRef idx="minor">
+            <a:schemeClr val="lt1"/>
+          </a:fontRef>
+        </p:style>
+        <p:txBody>
+          <a:bodyPr rtlCol="0" anchor="ctr"/>
+          <a:lstStyle/>
+          <a:p>
+            <a:pPr algn="ctr"/>
+          </a:p>
+        </p:txBody>
+      </p:sp>
+      <p:sp>
+        <p:nvSpPr>
+          <p:cNvPr id="12" name="Rounded Rectangle 11"/>
+          <p:cNvSpPr/>
+          <p:nvPr/>
+        </p:nvSpPr>
+        <p:spPr>
+          <a:xfrm>
+            <a:off x="731519" y="1508760"/>
+            <a:ext cx="10728655" cy="32004"/>
+          </a:xfrm>
+          <a:prstGeom prst="roundRect">
+            <a:avLst>
+              <a:gd name="adj" fmla="val 50000"/>
+            </a:avLst>
+          </a:prstGeom>
+          <a:solidFill>
+            <a:srgbClr val="FFFFFF">
+              <a:alpha val="85000"/>
+            </a:srgbClr>
+          </a:solidFill>
+          <a:ln>
+            <a:noFill/>
+          </a:ln>
+          <a:effectLst/>
+        </p:spPr>
+        <p:style>
+          <a:lnRef idx="1">
+            <a:schemeClr val="accent1"/>
+          </a:lnRef>
+          <a:fillRef idx="3">
+            <a:schemeClr val="accent1"/>
+          </a:fillRef>
+          <a:effectRef idx="2">
+            <a:schemeClr val="accent1"/>
+          </a:effectRef>
+          <a:fontRef idx="minor">
+            <a:schemeClr val="lt1"/>
+          </a:fontRef>
+        </p:style>
+        <p:txBody>
+          <a:bodyPr rtlCol="0" anchor="ctr"/>
+          <a:lstStyle/>
+          <a:p>
+            <a:pPr algn="ctr"/>
+          </a:p>
+        </p:txBody>
+      </p:sp>
+      <p:sp>
+        <p:nvSpPr>
+          <p:cNvPr id="13" name="Rounded Rectangle 12"/>
+          <p:cNvSpPr/>
+          <p:nvPr/>
+        </p:nvSpPr>
+        <p:spPr>
+          <a:xfrm>
+            <a:off x="548640" y="1591056"/>
+            <a:ext cx="64008" cy="2699766"/>
+          </a:xfrm>
+          <a:prstGeom prst="roundRect">
+            <a:avLst>
+              <a:gd name="adj" fmla="val 50000"/>
+            </a:avLst>
+          </a:prstGeom>
+          <a:solidFill>
+            <a:srgbClr val="8D6A2A"/>
+          </a:solidFill>
+          <a:ln>
+            <a:noFill/>
+          </a:ln>
+          <a:effectLst>
+            <a:outerShdw blurRad="203200" dist="50800" dir="5400000" algn="t" rotWithShape="0">
+              <a:srgbClr val="1A2340">
+                <a:alpha val="20000"/>
+              </a:srgbClr>
+            </a:outerShdw>
+          </a:effectLst>
+          <a:scene3d>
+            <a:camera prst="orthographicFront"/>
+            <a:lightRig rig="threePt" dir="t"/>
+          </a:scene3d>
+          <a:sp3d>
+            <a:bevelT w="44450" h="25400" prst="softRound"/>
+          </a:sp3d>
+        </p:spPr>
+        <p:style>
+          <a:lnRef idx="1">
+            <a:schemeClr val="accent1"/>
+          </a:lnRef>
+          <a:fillRef idx="3">
+            <a:schemeClr val="accent1"/>
+          </a:fillRef>
+          <a:effectRef idx="2">
+            <a:schemeClr val="accent1"/>
+          </a:effectRef>
+          <a:fontRef idx="minor">
+            <a:schemeClr val="lt1"/>
+          </a:fontRef>
+        </p:style>
+        <p:txBody>
+          <a:bodyPr rtlCol="0" anchor="ctr"/>
+          <a:lstStyle/>
+          <a:p>
+            <a:pPr algn="ctr"/>
+          </a:p>
+        </p:txBody>
+      </p:sp>
+      <p:sp>
+        <p:nvSpPr>
+          <p:cNvPr id="14" name="TextBox 13"/>
           <p:cNvSpPr txBox="1"/>
           <p:nvPr/>
         </p:nvSpPr>
         <p:spPr>
           <a:xfrm>
-            <a:off x="548640" y="1554480"/>
-            <a:ext cx="4480560" cy="4617720"/>
+            <a:off x="777240" y="1554480"/>
+            <a:ext cx="4251960" cy="4617720"/>
           </a:xfrm>
           <a:prstGeom prst="rect">
             <a:avLst/>
@@ -8250,7 +8725,7 @@
       </p:sp>
       <p:sp>
         <p:nvSpPr>
-          <p:cNvPr id="12" name="Oval 11"/>
+          <p:cNvPr id="15" name="Oval 14"/>
           <p:cNvSpPr/>
           <p:nvPr/>
         </p:nvSpPr>
@@ -8303,7 +8778,7 @@
       </p:sp>
       <p:sp>
         <p:nvSpPr>
-          <p:cNvPr id="13" name="TextBox 12"/>
+          <p:cNvPr id="16" name="TextBox 15"/>
           <p:cNvSpPr txBox="1"/>
           <p:nvPr/>
         </p:nvSpPr>
@@ -8337,7 +8812,7 @@
       </p:sp>
       <p:sp>
         <p:nvSpPr>
-          <p:cNvPr id="14" name="Oval 13"/>
+          <p:cNvPr id="17" name="Oval 16"/>
           <p:cNvSpPr/>
           <p:nvPr/>
         </p:nvSpPr>
@@ -8390,7 +8865,7 @@
       </p:sp>
       <p:sp>
         <p:nvSpPr>
-          <p:cNvPr id="15" name="TextBox 14"/>
+          <p:cNvPr id="18" name="TextBox 17"/>
           <p:cNvSpPr txBox="1"/>
           <p:nvPr/>
         </p:nvSpPr>
@@ -8442,7 +8917,7 @@
       </p:sp>
       <p:sp>
         <p:nvSpPr>
-          <p:cNvPr id="16" name="Oval 15"/>
+          <p:cNvPr id="19" name="Oval 18"/>
           <p:cNvSpPr/>
           <p:nvPr/>
         </p:nvSpPr>
@@ -8495,7 +8970,7 @@
       </p:sp>
       <p:sp>
         <p:nvSpPr>
-          <p:cNvPr id="17" name="TextBox 16"/>
+          <p:cNvPr id="20" name="TextBox 19"/>
           <p:cNvSpPr txBox="1"/>
           <p:nvPr/>
         </p:nvSpPr>
@@ -8908,9 +9383,113 @@
           </a:prstGeom>
         </p:spPr>
       </p:pic>
+      <p:sp>
+        <p:nvSpPr>
+          <p:cNvPr id="11" name="Rounded Rectangle 10"/>
+          <p:cNvSpPr/>
+          <p:nvPr/>
+        </p:nvSpPr>
+        <p:spPr>
+          <a:xfrm>
+            <a:off x="411479" y="1444752"/>
+            <a:ext cx="11368735" cy="4800600"/>
+          </a:xfrm>
+          <a:prstGeom prst="roundRect">
+            <a:avLst>
+              <a:gd name="adj" fmla="val 4000"/>
+            </a:avLst>
+          </a:prstGeom>
+          <a:solidFill>
+            <a:srgbClr val="FFFFFF">
+              <a:alpha val="84000"/>
+            </a:srgbClr>
+          </a:solidFill>
+          <a:ln w="19050">
+            <a:solidFill>
+              <a:srgbClr val="FFFFFF"/>
+            </a:solidFill>
+          </a:ln>
+          <a:effectLst>
+            <a:outerShdw blurRad="203200" dist="50800" dir="5400000" algn="t" rotWithShape="0">
+              <a:srgbClr val="1A2340">
+                <a:alpha val="20000"/>
+              </a:srgbClr>
+            </a:outerShdw>
+          </a:effectLst>
+        </p:spPr>
+        <p:style>
+          <a:lnRef idx="1">
+            <a:schemeClr val="accent1"/>
+          </a:lnRef>
+          <a:fillRef idx="3">
+            <a:schemeClr val="accent1"/>
+          </a:fillRef>
+          <a:effectRef idx="2">
+            <a:schemeClr val="accent1"/>
+          </a:effectRef>
+          <a:fontRef idx="minor">
+            <a:schemeClr val="lt1"/>
+          </a:fontRef>
+        </p:style>
+        <p:txBody>
+          <a:bodyPr rtlCol="0" anchor="ctr"/>
+          <a:lstStyle/>
+          <a:p>
+            <a:pPr algn="ctr"/>
+          </a:p>
+        </p:txBody>
+      </p:sp>
+      <p:sp>
+        <p:nvSpPr>
+          <p:cNvPr id="12" name="Rounded Rectangle 11"/>
+          <p:cNvSpPr/>
+          <p:nvPr/>
+        </p:nvSpPr>
+        <p:spPr>
+          <a:xfrm>
+            <a:off x="731519" y="1508760"/>
+            <a:ext cx="10728655" cy="32004"/>
+          </a:xfrm>
+          <a:prstGeom prst="roundRect">
+            <a:avLst>
+              <a:gd name="adj" fmla="val 50000"/>
+            </a:avLst>
+          </a:prstGeom>
+          <a:solidFill>
+            <a:srgbClr val="FFFFFF">
+              <a:alpha val="85000"/>
+            </a:srgbClr>
+          </a:solidFill>
+          <a:ln>
+            <a:noFill/>
+          </a:ln>
+          <a:effectLst/>
+        </p:spPr>
+        <p:style>
+          <a:lnRef idx="1">
+            <a:schemeClr val="accent1"/>
+          </a:lnRef>
+          <a:fillRef idx="3">
+            <a:schemeClr val="accent1"/>
+          </a:fillRef>
+          <a:effectRef idx="2">
+            <a:schemeClr val="accent1"/>
+          </a:effectRef>
+          <a:fontRef idx="minor">
+            <a:schemeClr val="lt1"/>
+          </a:fontRef>
+        </p:style>
+        <p:txBody>
+          <a:bodyPr rtlCol="0" anchor="ctr"/>
+          <a:lstStyle/>
+          <a:p>
+            <a:pPr algn="ctr"/>
+          </a:p>
+        </p:txBody>
+      </p:sp>
       <p:graphicFrame>
         <p:nvGraphicFramePr>
-          <p:cNvPr id="11" name="Table 10"/>
+          <p:cNvPr id="13" name="Table 12"/>
           <p:cNvGraphicFramePr>
             <a:graphicFrameLocks noGrp="1"/>
           </p:cNvGraphicFramePr>
@@ -9800,6 +10379,110 @@
         </p:nvSpPr>
         <p:spPr>
           <a:xfrm>
+            <a:off x="411479" y="1444752"/>
+            <a:ext cx="11368735" cy="4800600"/>
+          </a:xfrm>
+          <a:prstGeom prst="roundRect">
+            <a:avLst>
+              <a:gd name="adj" fmla="val 4000"/>
+            </a:avLst>
+          </a:prstGeom>
+          <a:solidFill>
+            <a:srgbClr val="FFFFFF">
+              <a:alpha val="84000"/>
+            </a:srgbClr>
+          </a:solidFill>
+          <a:ln w="19050">
+            <a:solidFill>
+              <a:srgbClr val="FFFFFF"/>
+            </a:solidFill>
+          </a:ln>
+          <a:effectLst>
+            <a:outerShdw blurRad="203200" dist="50800" dir="5400000" algn="t" rotWithShape="0">
+              <a:srgbClr val="1A2340">
+                <a:alpha val="20000"/>
+              </a:srgbClr>
+            </a:outerShdw>
+          </a:effectLst>
+        </p:spPr>
+        <p:style>
+          <a:lnRef idx="1">
+            <a:schemeClr val="accent1"/>
+          </a:lnRef>
+          <a:fillRef idx="3">
+            <a:schemeClr val="accent1"/>
+          </a:fillRef>
+          <a:effectRef idx="2">
+            <a:schemeClr val="accent1"/>
+          </a:effectRef>
+          <a:fontRef idx="minor">
+            <a:schemeClr val="lt1"/>
+          </a:fontRef>
+        </p:style>
+        <p:txBody>
+          <a:bodyPr rtlCol="0" anchor="ctr"/>
+          <a:lstStyle/>
+          <a:p>
+            <a:pPr algn="ctr"/>
+          </a:p>
+        </p:txBody>
+      </p:sp>
+      <p:sp>
+        <p:nvSpPr>
+          <p:cNvPr id="12" name="Rounded Rectangle 11"/>
+          <p:cNvSpPr/>
+          <p:nvPr/>
+        </p:nvSpPr>
+        <p:spPr>
+          <a:xfrm>
+            <a:off x="731519" y="1508760"/>
+            <a:ext cx="10728655" cy="32004"/>
+          </a:xfrm>
+          <a:prstGeom prst="roundRect">
+            <a:avLst>
+              <a:gd name="adj" fmla="val 50000"/>
+            </a:avLst>
+          </a:prstGeom>
+          <a:solidFill>
+            <a:srgbClr val="FFFFFF">
+              <a:alpha val="85000"/>
+            </a:srgbClr>
+          </a:solidFill>
+          <a:ln>
+            <a:noFill/>
+          </a:ln>
+          <a:effectLst/>
+        </p:spPr>
+        <p:style>
+          <a:lnRef idx="1">
+            <a:schemeClr val="accent1"/>
+          </a:lnRef>
+          <a:fillRef idx="3">
+            <a:schemeClr val="accent1"/>
+          </a:fillRef>
+          <a:effectRef idx="2">
+            <a:schemeClr val="accent1"/>
+          </a:effectRef>
+          <a:fontRef idx="minor">
+            <a:schemeClr val="lt1"/>
+          </a:fontRef>
+        </p:style>
+        <p:txBody>
+          <a:bodyPr rtlCol="0" anchor="ctr"/>
+          <a:lstStyle/>
+          <a:p>
+            <a:pPr algn="ctr"/>
+          </a:p>
+        </p:txBody>
+      </p:sp>
+      <p:sp>
+        <p:nvSpPr>
+          <p:cNvPr id="13" name="Rounded Rectangle 12"/>
+          <p:cNvSpPr/>
+          <p:nvPr/>
+        </p:nvSpPr>
+        <p:spPr>
+          <a:xfrm>
             <a:off x="1645919" y="2103120"/>
             <a:ext cx="8899855" cy="2377440"/>
           </a:xfrm>
@@ -9850,7 +10533,7 @@
       </p:sp>
       <p:sp>
         <p:nvSpPr>
-          <p:cNvPr id="12" name="Rounded Rectangle 11"/>
+          <p:cNvPr id="14" name="Rounded Rectangle 13"/>
           <p:cNvSpPr/>
           <p:nvPr/>
         </p:nvSpPr>
@@ -9898,7 +10581,7 @@
       </p:sp>
       <p:sp>
         <p:nvSpPr>
-          <p:cNvPr id="13" name="Rounded Rectangle 12"/>
+          <p:cNvPr id="15" name="Rounded Rectangle 14"/>
           <p:cNvSpPr/>
           <p:nvPr/>
         </p:nvSpPr>
@@ -9966,7 +10649,7 @@
       </p:sp>
       <p:sp>
         <p:nvSpPr>
-          <p:cNvPr id="14" name="TextBox 13"/>
+          <p:cNvPr id="16" name="TextBox 15"/>
           <p:cNvSpPr txBox="1"/>
           <p:nvPr/>
         </p:nvSpPr>
@@ -10386,14 +11069,177 @@
       </p:pic>
       <p:sp>
         <p:nvSpPr>
-          <p:cNvPr id="11" name="TextBox 10"/>
+          <p:cNvPr id="11" name="Rounded Rectangle 10"/>
+          <p:cNvSpPr/>
+          <p:nvPr/>
+        </p:nvSpPr>
+        <p:spPr>
+          <a:xfrm>
+            <a:off x="411479" y="1444752"/>
+            <a:ext cx="11368735" cy="4800600"/>
+          </a:xfrm>
+          <a:prstGeom prst="roundRect">
+            <a:avLst>
+              <a:gd name="adj" fmla="val 4000"/>
+            </a:avLst>
+          </a:prstGeom>
+          <a:solidFill>
+            <a:srgbClr val="FFFFFF">
+              <a:alpha val="84000"/>
+            </a:srgbClr>
+          </a:solidFill>
+          <a:ln w="19050">
+            <a:solidFill>
+              <a:srgbClr val="FFFFFF"/>
+            </a:solidFill>
+          </a:ln>
+          <a:effectLst>
+            <a:outerShdw blurRad="203200" dist="50800" dir="5400000" algn="t" rotWithShape="0">
+              <a:srgbClr val="1A2340">
+                <a:alpha val="20000"/>
+              </a:srgbClr>
+            </a:outerShdw>
+          </a:effectLst>
+        </p:spPr>
+        <p:style>
+          <a:lnRef idx="1">
+            <a:schemeClr val="accent1"/>
+          </a:lnRef>
+          <a:fillRef idx="3">
+            <a:schemeClr val="accent1"/>
+          </a:fillRef>
+          <a:effectRef idx="2">
+            <a:schemeClr val="accent1"/>
+          </a:effectRef>
+          <a:fontRef idx="minor">
+            <a:schemeClr val="lt1"/>
+          </a:fontRef>
+        </p:style>
+        <p:txBody>
+          <a:bodyPr rtlCol="0" anchor="ctr"/>
+          <a:lstStyle/>
+          <a:p>
+            <a:pPr algn="ctr"/>
+          </a:p>
+        </p:txBody>
+      </p:sp>
+      <p:sp>
+        <p:nvSpPr>
+          <p:cNvPr id="12" name="Rounded Rectangle 11"/>
+          <p:cNvSpPr/>
+          <p:nvPr/>
+        </p:nvSpPr>
+        <p:spPr>
+          <a:xfrm>
+            <a:off x="731519" y="1508760"/>
+            <a:ext cx="10728655" cy="32004"/>
+          </a:xfrm>
+          <a:prstGeom prst="roundRect">
+            <a:avLst>
+              <a:gd name="adj" fmla="val 50000"/>
+            </a:avLst>
+          </a:prstGeom>
+          <a:solidFill>
+            <a:srgbClr val="FFFFFF">
+              <a:alpha val="85000"/>
+            </a:srgbClr>
+          </a:solidFill>
+          <a:ln>
+            <a:noFill/>
+          </a:ln>
+          <a:effectLst/>
+        </p:spPr>
+        <p:style>
+          <a:lnRef idx="1">
+            <a:schemeClr val="accent1"/>
+          </a:lnRef>
+          <a:fillRef idx="3">
+            <a:schemeClr val="accent1"/>
+          </a:fillRef>
+          <a:effectRef idx="2">
+            <a:schemeClr val="accent1"/>
+          </a:effectRef>
+          <a:fontRef idx="minor">
+            <a:schemeClr val="lt1"/>
+          </a:fontRef>
+        </p:style>
+        <p:txBody>
+          <a:bodyPr rtlCol="0" anchor="ctr"/>
+          <a:lstStyle/>
+          <a:p>
+            <a:pPr algn="ctr"/>
+          </a:p>
+        </p:txBody>
+      </p:sp>
+      <p:sp>
+        <p:nvSpPr>
+          <p:cNvPr id="13" name="Rounded Rectangle 12"/>
+          <p:cNvSpPr/>
+          <p:nvPr/>
+        </p:nvSpPr>
+        <p:spPr>
+          <a:xfrm>
+            <a:off x="548640" y="1591056"/>
+            <a:ext cx="64008" cy="1019555"/>
+          </a:xfrm>
+          <a:prstGeom prst="roundRect">
+            <a:avLst>
+              <a:gd name="adj" fmla="val 50000"/>
+            </a:avLst>
+          </a:prstGeom>
+          <a:solidFill>
+            <a:srgbClr val="8D6A2A"/>
+          </a:solidFill>
+          <a:ln>
+            <a:noFill/>
+          </a:ln>
+          <a:effectLst>
+            <a:outerShdw blurRad="203200" dist="50800" dir="5400000" algn="t" rotWithShape="0">
+              <a:srgbClr val="1A2340">
+                <a:alpha val="20000"/>
+              </a:srgbClr>
+            </a:outerShdw>
+          </a:effectLst>
+          <a:scene3d>
+            <a:camera prst="orthographicFront"/>
+            <a:lightRig rig="threePt" dir="t"/>
+          </a:scene3d>
+          <a:sp3d>
+            <a:bevelT w="44450" h="25400" prst="softRound"/>
+          </a:sp3d>
+        </p:spPr>
+        <p:style>
+          <a:lnRef idx="1">
+            <a:schemeClr val="accent1"/>
+          </a:lnRef>
+          <a:fillRef idx="3">
+            <a:schemeClr val="accent1"/>
+          </a:fillRef>
+          <a:effectRef idx="2">
+            <a:schemeClr val="accent1"/>
+          </a:effectRef>
+          <a:fontRef idx="minor">
+            <a:schemeClr val="lt1"/>
+          </a:fontRef>
+        </p:style>
+        <p:txBody>
+          <a:bodyPr rtlCol="0" anchor="ctr"/>
+          <a:lstStyle/>
+          <a:p>
+            <a:pPr algn="ctr"/>
+          </a:p>
+        </p:txBody>
+      </p:sp>
+      <p:sp>
+        <p:nvSpPr>
+          <p:cNvPr id="14" name="TextBox 13"/>
           <p:cNvSpPr txBox="1"/>
           <p:nvPr/>
         </p:nvSpPr>
         <p:spPr>
           <a:xfrm>
-            <a:off x="548640" y="1554480"/>
-            <a:ext cx="11094415" cy="1202436"/>
+            <a:off x="777240" y="1554480"/>
+            <a:ext cx="10865815" cy="1202436"/>
           </a:xfrm>
           <a:prstGeom prst="rect">
             <a:avLst/>
@@ -10441,7 +11287,7 @@
       </p:sp>
       <p:sp>
         <p:nvSpPr>
-          <p:cNvPr id="12" name="Oval 11"/>
+          <p:cNvPr id="15" name="Oval 14"/>
           <p:cNvSpPr/>
           <p:nvPr/>
         </p:nvSpPr>
@@ -10494,7 +11340,7 @@
       </p:sp>
       <p:sp>
         <p:nvSpPr>
-          <p:cNvPr id="13" name="TextBox 12"/>
+          <p:cNvPr id="16" name="TextBox 15"/>
           <p:cNvSpPr txBox="1"/>
           <p:nvPr/>
         </p:nvSpPr>
@@ -10528,7 +11374,7 @@
       </p:sp>
       <p:sp>
         <p:nvSpPr>
-          <p:cNvPr id="14" name="Oval 13"/>
+          <p:cNvPr id="17" name="Oval 16"/>
           <p:cNvSpPr/>
           <p:nvPr/>
         </p:nvSpPr>
@@ -10581,7 +11427,7 @@
       </p:sp>
       <p:sp>
         <p:nvSpPr>
-          <p:cNvPr id="15" name="TextBox 14"/>
+          <p:cNvPr id="18" name="TextBox 17"/>
           <p:cNvSpPr txBox="1"/>
           <p:nvPr/>
         </p:nvSpPr>
@@ -10615,7 +11461,7 @@
       </p:sp>
       <p:sp>
         <p:nvSpPr>
-          <p:cNvPr id="16" name="Oval 15"/>
+          <p:cNvPr id="19" name="Oval 18"/>
           <p:cNvSpPr/>
           <p:nvPr/>
         </p:nvSpPr>
@@ -10668,7 +11514,7 @@
       </p:sp>
       <p:sp>
         <p:nvSpPr>
-          <p:cNvPr id="17" name="TextBox 16"/>
+          <p:cNvPr id="20" name="TextBox 19"/>
           <p:cNvSpPr txBox="1"/>
           <p:nvPr/>
         </p:nvSpPr>
@@ -10702,7 +11548,7 @@
       </p:sp>
       <p:sp>
         <p:nvSpPr>
-          <p:cNvPr id="18" name="Oval 17"/>
+          <p:cNvPr id="21" name="Oval 20"/>
           <p:cNvSpPr/>
           <p:nvPr/>
         </p:nvSpPr>
@@ -10755,7 +11601,7 @@
       </p:sp>
       <p:sp>
         <p:nvSpPr>
-          <p:cNvPr id="19" name="TextBox 18"/>
+          <p:cNvPr id="22" name="TextBox 21"/>
           <p:cNvSpPr txBox="1"/>
           <p:nvPr/>
         </p:nvSpPr>
@@ -10789,7 +11635,7 @@
       </p:sp>
       <p:sp>
         <p:nvSpPr>
-          <p:cNvPr id="20" name="Oval 19"/>
+          <p:cNvPr id="23" name="Oval 22"/>
           <p:cNvSpPr/>
           <p:nvPr/>
         </p:nvSpPr>
@@ -10842,7 +11688,7 @@
       </p:sp>
       <p:sp>
         <p:nvSpPr>
-          <p:cNvPr id="21" name="TextBox 20"/>
+          <p:cNvPr id="24" name="TextBox 23"/>
           <p:cNvSpPr txBox="1"/>
           <p:nvPr/>
         </p:nvSpPr>
@@ -11255,9 +12101,113 @@
           </a:prstGeom>
         </p:spPr>
       </p:pic>
+      <p:sp>
+        <p:nvSpPr>
+          <p:cNvPr id="11" name="Rounded Rectangle 10"/>
+          <p:cNvSpPr/>
+          <p:nvPr/>
+        </p:nvSpPr>
+        <p:spPr>
+          <a:xfrm>
+            <a:off x="411479" y="1444752"/>
+            <a:ext cx="11368735" cy="4800600"/>
+          </a:xfrm>
+          <a:prstGeom prst="roundRect">
+            <a:avLst>
+              <a:gd name="adj" fmla="val 4000"/>
+            </a:avLst>
+          </a:prstGeom>
+          <a:solidFill>
+            <a:srgbClr val="FFFFFF">
+              <a:alpha val="84000"/>
+            </a:srgbClr>
+          </a:solidFill>
+          <a:ln w="19050">
+            <a:solidFill>
+              <a:srgbClr val="FFFFFF"/>
+            </a:solidFill>
+          </a:ln>
+          <a:effectLst>
+            <a:outerShdw blurRad="203200" dist="50800" dir="5400000" algn="t" rotWithShape="0">
+              <a:srgbClr val="1A2340">
+                <a:alpha val="20000"/>
+              </a:srgbClr>
+            </a:outerShdw>
+          </a:effectLst>
+        </p:spPr>
+        <p:style>
+          <a:lnRef idx="1">
+            <a:schemeClr val="accent1"/>
+          </a:lnRef>
+          <a:fillRef idx="3">
+            <a:schemeClr val="accent1"/>
+          </a:fillRef>
+          <a:effectRef idx="2">
+            <a:schemeClr val="accent1"/>
+          </a:effectRef>
+          <a:fontRef idx="minor">
+            <a:schemeClr val="lt1"/>
+          </a:fontRef>
+        </p:style>
+        <p:txBody>
+          <a:bodyPr rtlCol="0" anchor="ctr"/>
+          <a:lstStyle/>
+          <a:p>
+            <a:pPr algn="ctr"/>
+          </a:p>
+        </p:txBody>
+      </p:sp>
+      <p:sp>
+        <p:nvSpPr>
+          <p:cNvPr id="12" name="Rounded Rectangle 11"/>
+          <p:cNvSpPr/>
+          <p:nvPr/>
+        </p:nvSpPr>
+        <p:spPr>
+          <a:xfrm>
+            <a:off x="731519" y="1508760"/>
+            <a:ext cx="10728655" cy="32004"/>
+          </a:xfrm>
+          <a:prstGeom prst="roundRect">
+            <a:avLst>
+              <a:gd name="adj" fmla="val 50000"/>
+            </a:avLst>
+          </a:prstGeom>
+          <a:solidFill>
+            <a:srgbClr val="FFFFFF">
+              <a:alpha val="85000"/>
+            </a:srgbClr>
+          </a:solidFill>
+          <a:ln>
+            <a:noFill/>
+          </a:ln>
+          <a:effectLst/>
+        </p:spPr>
+        <p:style>
+          <a:lnRef idx="1">
+            <a:schemeClr val="accent1"/>
+          </a:lnRef>
+          <a:fillRef idx="3">
+            <a:schemeClr val="accent1"/>
+          </a:fillRef>
+          <a:effectRef idx="2">
+            <a:schemeClr val="accent1"/>
+          </a:effectRef>
+          <a:fontRef idx="minor">
+            <a:schemeClr val="lt1"/>
+          </a:fontRef>
+        </p:style>
+        <p:txBody>
+          <a:bodyPr rtlCol="0" anchor="ctr"/>
+          <a:lstStyle/>
+          <a:p>
+            <a:pPr algn="ctr"/>
+          </a:p>
+        </p:txBody>
+      </p:sp>
       <p:graphicFrame>
         <p:nvGraphicFramePr>
-          <p:cNvPr id="11" name="Table 10"/>
+          <p:cNvPr id="13" name="Table 12"/>
           <p:cNvGraphicFramePr>
             <a:graphicFrameLocks noGrp="1"/>
           </p:cNvGraphicFramePr>
@@ -11937,7 +12887,111 @@
       </p:pic>
       <p:sp>
         <p:nvSpPr>
-          <p:cNvPr id="11" name="Oval 10"/>
+          <p:cNvPr id="11" name="Rounded Rectangle 10"/>
+          <p:cNvSpPr/>
+          <p:nvPr/>
+        </p:nvSpPr>
+        <p:spPr>
+          <a:xfrm>
+            <a:off x="411479" y="1444752"/>
+            <a:ext cx="11368735" cy="4800600"/>
+          </a:xfrm>
+          <a:prstGeom prst="roundRect">
+            <a:avLst>
+              <a:gd name="adj" fmla="val 4000"/>
+            </a:avLst>
+          </a:prstGeom>
+          <a:solidFill>
+            <a:srgbClr val="FFFFFF">
+              <a:alpha val="84000"/>
+            </a:srgbClr>
+          </a:solidFill>
+          <a:ln w="19050">
+            <a:solidFill>
+              <a:srgbClr val="FFFFFF"/>
+            </a:solidFill>
+          </a:ln>
+          <a:effectLst>
+            <a:outerShdw blurRad="203200" dist="50800" dir="5400000" algn="t" rotWithShape="0">
+              <a:srgbClr val="1A2340">
+                <a:alpha val="20000"/>
+              </a:srgbClr>
+            </a:outerShdw>
+          </a:effectLst>
+        </p:spPr>
+        <p:style>
+          <a:lnRef idx="1">
+            <a:schemeClr val="accent1"/>
+          </a:lnRef>
+          <a:fillRef idx="3">
+            <a:schemeClr val="accent1"/>
+          </a:fillRef>
+          <a:effectRef idx="2">
+            <a:schemeClr val="accent1"/>
+          </a:effectRef>
+          <a:fontRef idx="minor">
+            <a:schemeClr val="lt1"/>
+          </a:fontRef>
+        </p:style>
+        <p:txBody>
+          <a:bodyPr rtlCol="0" anchor="ctr"/>
+          <a:lstStyle/>
+          <a:p>
+            <a:pPr algn="ctr"/>
+          </a:p>
+        </p:txBody>
+      </p:sp>
+      <p:sp>
+        <p:nvSpPr>
+          <p:cNvPr id="12" name="Rounded Rectangle 11"/>
+          <p:cNvSpPr/>
+          <p:nvPr/>
+        </p:nvSpPr>
+        <p:spPr>
+          <a:xfrm>
+            <a:off x="731519" y="1508760"/>
+            <a:ext cx="10728655" cy="32004"/>
+          </a:xfrm>
+          <a:prstGeom prst="roundRect">
+            <a:avLst>
+              <a:gd name="adj" fmla="val 50000"/>
+            </a:avLst>
+          </a:prstGeom>
+          <a:solidFill>
+            <a:srgbClr val="FFFFFF">
+              <a:alpha val="85000"/>
+            </a:srgbClr>
+          </a:solidFill>
+          <a:ln>
+            <a:noFill/>
+          </a:ln>
+          <a:effectLst/>
+        </p:spPr>
+        <p:style>
+          <a:lnRef idx="1">
+            <a:schemeClr val="accent1"/>
+          </a:lnRef>
+          <a:fillRef idx="3">
+            <a:schemeClr val="accent1"/>
+          </a:fillRef>
+          <a:effectRef idx="2">
+            <a:schemeClr val="accent1"/>
+          </a:effectRef>
+          <a:fontRef idx="minor">
+            <a:schemeClr val="lt1"/>
+          </a:fontRef>
+        </p:style>
+        <p:txBody>
+          <a:bodyPr rtlCol="0" anchor="ctr"/>
+          <a:lstStyle/>
+          <a:p>
+            <a:pPr algn="ctr"/>
+          </a:p>
+        </p:txBody>
+      </p:sp>
+      <p:sp>
+        <p:nvSpPr>
+          <p:cNvPr id="13" name="Oval 12"/>
           <p:cNvSpPr/>
           <p:nvPr/>
         </p:nvSpPr>
@@ -11990,7 +13044,7 @@
       </p:sp>
       <p:sp>
         <p:nvSpPr>
-          <p:cNvPr id="12" name="TextBox 11"/>
+          <p:cNvPr id="14" name="TextBox 13"/>
           <p:cNvSpPr txBox="1"/>
           <p:nvPr/>
         </p:nvSpPr>
@@ -12024,7 +13078,7 @@
       </p:sp>
       <p:sp>
         <p:nvSpPr>
-          <p:cNvPr id="13" name="Oval 12"/>
+          <p:cNvPr id="15" name="Oval 14"/>
           <p:cNvSpPr/>
           <p:nvPr/>
         </p:nvSpPr>
@@ -12077,7 +13131,7 @@
       </p:sp>
       <p:sp>
         <p:nvSpPr>
-          <p:cNvPr id="14" name="TextBox 13"/>
+          <p:cNvPr id="16" name="TextBox 15"/>
           <p:cNvSpPr txBox="1"/>
           <p:nvPr/>
         </p:nvSpPr>
@@ -12111,7 +13165,7 @@
       </p:sp>
       <p:sp>
         <p:nvSpPr>
-          <p:cNvPr id="15" name="Oval 14"/>
+          <p:cNvPr id="17" name="Oval 16"/>
           <p:cNvSpPr/>
           <p:nvPr/>
         </p:nvSpPr>
@@ -12164,7 +13218,7 @@
       </p:sp>
       <p:sp>
         <p:nvSpPr>
-          <p:cNvPr id="16" name="TextBox 15"/>
+          <p:cNvPr id="18" name="TextBox 17"/>
           <p:cNvSpPr txBox="1"/>
           <p:nvPr/>
         </p:nvSpPr>
@@ -12579,7 +13633,111 @@
       </p:pic>
       <p:sp>
         <p:nvSpPr>
-          <p:cNvPr id="11" name="TextBox 10"/>
+          <p:cNvPr id="11" name="Rounded Rectangle 10"/>
+          <p:cNvSpPr/>
+          <p:nvPr/>
+        </p:nvSpPr>
+        <p:spPr>
+          <a:xfrm>
+            <a:off x="411479" y="1444752"/>
+            <a:ext cx="11368735" cy="4800600"/>
+          </a:xfrm>
+          <a:prstGeom prst="roundRect">
+            <a:avLst>
+              <a:gd name="adj" fmla="val 4000"/>
+            </a:avLst>
+          </a:prstGeom>
+          <a:solidFill>
+            <a:srgbClr val="FFFFFF">
+              <a:alpha val="84000"/>
+            </a:srgbClr>
+          </a:solidFill>
+          <a:ln w="19050">
+            <a:solidFill>
+              <a:srgbClr val="FFFFFF"/>
+            </a:solidFill>
+          </a:ln>
+          <a:effectLst>
+            <a:outerShdw blurRad="203200" dist="50800" dir="5400000" algn="t" rotWithShape="0">
+              <a:srgbClr val="1A2340">
+                <a:alpha val="20000"/>
+              </a:srgbClr>
+            </a:outerShdw>
+          </a:effectLst>
+        </p:spPr>
+        <p:style>
+          <a:lnRef idx="1">
+            <a:schemeClr val="accent1"/>
+          </a:lnRef>
+          <a:fillRef idx="3">
+            <a:schemeClr val="accent1"/>
+          </a:fillRef>
+          <a:effectRef idx="2">
+            <a:schemeClr val="accent1"/>
+          </a:effectRef>
+          <a:fontRef idx="minor">
+            <a:schemeClr val="lt1"/>
+          </a:fontRef>
+        </p:style>
+        <p:txBody>
+          <a:bodyPr rtlCol="0" anchor="ctr"/>
+          <a:lstStyle/>
+          <a:p>
+            <a:pPr algn="ctr"/>
+          </a:p>
+        </p:txBody>
+      </p:sp>
+      <p:sp>
+        <p:nvSpPr>
+          <p:cNvPr id="12" name="Rounded Rectangle 11"/>
+          <p:cNvSpPr/>
+          <p:nvPr/>
+        </p:nvSpPr>
+        <p:spPr>
+          <a:xfrm>
+            <a:off x="731519" y="1508760"/>
+            <a:ext cx="10728655" cy="32004"/>
+          </a:xfrm>
+          <a:prstGeom prst="roundRect">
+            <a:avLst>
+              <a:gd name="adj" fmla="val 50000"/>
+            </a:avLst>
+          </a:prstGeom>
+          <a:solidFill>
+            <a:srgbClr val="FFFFFF">
+              <a:alpha val="85000"/>
+            </a:srgbClr>
+          </a:solidFill>
+          <a:ln>
+            <a:noFill/>
+          </a:ln>
+          <a:effectLst/>
+        </p:spPr>
+        <p:style>
+          <a:lnRef idx="1">
+            <a:schemeClr val="accent1"/>
+          </a:lnRef>
+          <a:fillRef idx="3">
+            <a:schemeClr val="accent1"/>
+          </a:fillRef>
+          <a:effectRef idx="2">
+            <a:schemeClr val="accent1"/>
+          </a:effectRef>
+          <a:fontRef idx="minor">
+            <a:schemeClr val="lt1"/>
+          </a:fontRef>
+        </p:style>
+        <p:txBody>
+          <a:bodyPr rtlCol="0" anchor="ctr"/>
+          <a:lstStyle/>
+          <a:p>
+            <a:pPr algn="ctr"/>
+          </a:p>
+        </p:txBody>
+      </p:sp>
+      <p:sp>
+        <p:nvSpPr>
+          <p:cNvPr id="13" name="TextBox 12"/>
           <p:cNvSpPr txBox="1"/>
           <p:nvPr/>
         </p:nvSpPr>
@@ -12613,7 +13771,7 @@
       </p:sp>
       <p:sp>
         <p:nvSpPr>
-          <p:cNvPr id="12" name="Rounded Rectangle 11"/>
+          <p:cNvPr id="14" name="Rounded Rectangle 13"/>
           <p:cNvSpPr/>
           <p:nvPr/>
         </p:nvSpPr>
@@ -12669,7 +13827,7 @@
       </p:sp>
       <p:sp>
         <p:nvSpPr>
-          <p:cNvPr id="13" name="Oval 12"/>
+          <p:cNvPr id="15" name="Oval 14"/>
           <p:cNvSpPr/>
           <p:nvPr/>
         </p:nvSpPr>
@@ -12722,7 +13880,7 @@
       </p:sp>
       <p:sp>
         <p:nvSpPr>
-          <p:cNvPr id="14" name="TextBox 13"/>
+          <p:cNvPr id="16" name="TextBox 15"/>
           <p:cNvSpPr txBox="1"/>
           <p:nvPr/>
         </p:nvSpPr>
@@ -12756,7 +13914,7 @@
       </p:sp>
       <p:sp>
         <p:nvSpPr>
-          <p:cNvPr id="15" name="Rounded Rectangle 14"/>
+          <p:cNvPr id="17" name="Rounded Rectangle 16"/>
           <p:cNvSpPr/>
           <p:nvPr/>
         </p:nvSpPr>
@@ -12812,7 +13970,7 @@
       </p:sp>
       <p:sp>
         <p:nvSpPr>
-          <p:cNvPr id="16" name="Oval 15"/>
+          <p:cNvPr id="18" name="Oval 17"/>
           <p:cNvSpPr/>
           <p:nvPr/>
         </p:nvSpPr>
@@ -12865,7 +14023,7 @@
       </p:sp>
       <p:sp>
         <p:nvSpPr>
-          <p:cNvPr id="17" name="TextBox 16"/>
+          <p:cNvPr id="19" name="TextBox 18"/>
           <p:cNvSpPr txBox="1"/>
           <p:nvPr/>
         </p:nvSpPr>
@@ -12899,7 +14057,7 @@
       </p:sp>
       <p:sp>
         <p:nvSpPr>
-          <p:cNvPr id="18" name="Rounded Rectangle 17"/>
+          <p:cNvPr id="20" name="Rounded Rectangle 19"/>
           <p:cNvSpPr/>
           <p:nvPr/>
         </p:nvSpPr>
@@ -12955,7 +14113,7 @@
       </p:sp>
       <p:sp>
         <p:nvSpPr>
-          <p:cNvPr id="19" name="Oval 18"/>
+          <p:cNvPr id="21" name="Oval 20"/>
           <p:cNvSpPr/>
           <p:nvPr/>
         </p:nvSpPr>
@@ -13008,7 +14166,7 @@
       </p:sp>
       <p:sp>
         <p:nvSpPr>
-          <p:cNvPr id="20" name="TextBox 19"/>
+          <p:cNvPr id="22" name="TextBox 21"/>
           <p:cNvSpPr txBox="1"/>
           <p:nvPr/>
         </p:nvSpPr>
@@ -13042,7 +14200,7 @@
       </p:sp>
       <p:sp>
         <p:nvSpPr>
-          <p:cNvPr id="21" name="Rounded Rectangle 20"/>
+          <p:cNvPr id="23" name="Rounded Rectangle 22"/>
           <p:cNvSpPr/>
           <p:nvPr/>
         </p:nvSpPr>
@@ -13098,7 +14256,7 @@
       </p:sp>
       <p:sp>
         <p:nvSpPr>
-          <p:cNvPr id="22" name="Oval 21"/>
+          <p:cNvPr id="24" name="Oval 23"/>
           <p:cNvSpPr/>
           <p:nvPr/>
         </p:nvSpPr>
@@ -13151,7 +14309,7 @@
       </p:sp>
       <p:sp>
         <p:nvSpPr>
-          <p:cNvPr id="23" name="TextBox 22"/>
+          <p:cNvPr id="25" name="TextBox 24"/>
           <p:cNvSpPr txBox="1"/>
           <p:nvPr/>
         </p:nvSpPr>
@@ -13566,7 +14724,111 @@
       </p:pic>
       <p:sp>
         <p:nvSpPr>
-          <p:cNvPr id="11" name="Oval 10"/>
+          <p:cNvPr id="11" name="Rounded Rectangle 10"/>
+          <p:cNvSpPr/>
+          <p:nvPr/>
+        </p:nvSpPr>
+        <p:spPr>
+          <a:xfrm>
+            <a:off x="411479" y="1444752"/>
+            <a:ext cx="11368735" cy="4800600"/>
+          </a:xfrm>
+          <a:prstGeom prst="roundRect">
+            <a:avLst>
+              <a:gd name="adj" fmla="val 4000"/>
+            </a:avLst>
+          </a:prstGeom>
+          <a:solidFill>
+            <a:srgbClr val="FFFFFF">
+              <a:alpha val="84000"/>
+            </a:srgbClr>
+          </a:solidFill>
+          <a:ln w="19050">
+            <a:solidFill>
+              <a:srgbClr val="FFFFFF"/>
+            </a:solidFill>
+          </a:ln>
+          <a:effectLst>
+            <a:outerShdw blurRad="203200" dist="50800" dir="5400000" algn="t" rotWithShape="0">
+              <a:srgbClr val="1A2340">
+                <a:alpha val="20000"/>
+              </a:srgbClr>
+            </a:outerShdw>
+          </a:effectLst>
+        </p:spPr>
+        <p:style>
+          <a:lnRef idx="1">
+            <a:schemeClr val="accent1"/>
+          </a:lnRef>
+          <a:fillRef idx="3">
+            <a:schemeClr val="accent1"/>
+          </a:fillRef>
+          <a:effectRef idx="2">
+            <a:schemeClr val="accent1"/>
+          </a:effectRef>
+          <a:fontRef idx="minor">
+            <a:schemeClr val="lt1"/>
+          </a:fontRef>
+        </p:style>
+        <p:txBody>
+          <a:bodyPr rtlCol="0" anchor="ctr"/>
+          <a:lstStyle/>
+          <a:p>
+            <a:pPr algn="ctr"/>
+          </a:p>
+        </p:txBody>
+      </p:sp>
+      <p:sp>
+        <p:nvSpPr>
+          <p:cNvPr id="12" name="Rounded Rectangle 11"/>
+          <p:cNvSpPr/>
+          <p:nvPr/>
+        </p:nvSpPr>
+        <p:spPr>
+          <a:xfrm>
+            <a:off x="731519" y="1508760"/>
+            <a:ext cx="10728655" cy="32004"/>
+          </a:xfrm>
+          <a:prstGeom prst="roundRect">
+            <a:avLst>
+              <a:gd name="adj" fmla="val 50000"/>
+            </a:avLst>
+          </a:prstGeom>
+          <a:solidFill>
+            <a:srgbClr val="FFFFFF">
+              <a:alpha val="85000"/>
+            </a:srgbClr>
+          </a:solidFill>
+          <a:ln>
+            <a:noFill/>
+          </a:ln>
+          <a:effectLst/>
+        </p:spPr>
+        <p:style>
+          <a:lnRef idx="1">
+            <a:schemeClr val="accent1"/>
+          </a:lnRef>
+          <a:fillRef idx="3">
+            <a:schemeClr val="accent1"/>
+          </a:fillRef>
+          <a:effectRef idx="2">
+            <a:schemeClr val="accent1"/>
+          </a:effectRef>
+          <a:fontRef idx="minor">
+            <a:schemeClr val="lt1"/>
+          </a:fontRef>
+        </p:style>
+        <p:txBody>
+          <a:bodyPr rtlCol="0" anchor="ctr"/>
+          <a:lstStyle/>
+          <a:p>
+            <a:pPr algn="ctr"/>
+          </a:p>
+        </p:txBody>
+      </p:sp>
+      <p:sp>
+        <p:nvSpPr>
+          <p:cNvPr id="13" name="Oval 12"/>
           <p:cNvSpPr/>
           <p:nvPr/>
         </p:nvSpPr>
@@ -13619,7 +14881,7 @@
       </p:sp>
       <p:sp>
         <p:nvSpPr>
-          <p:cNvPr id="12" name="TextBox 11"/>
+          <p:cNvPr id="14" name="TextBox 13"/>
           <p:cNvSpPr txBox="1"/>
           <p:nvPr/>
         </p:nvSpPr>
@@ -13653,7 +14915,7 @@
       </p:sp>
       <p:sp>
         <p:nvSpPr>
-          <p:cNvPr id="13" name="Oval 12"/>
+          <p:cNvPr id="15" name="Oval 14"/>
           <p:cNvSpPr/>
           <p:nvPr/>
         </p:nvSpPr>
@@ -13706,7 +14968,7 @@
       </p:sp>
       <p:sp>
         <p:nvSpPr>
-          <p:cNvPr id="14" name="TextBox 13"/>
+          <p:cNvPr id="16" name="TextBox 15"/>
           <p:cNvSpPr txBox="1"/>
           <p:nvPr/>
         </p:nvSpPr>
@@ -13740,7 +15002,7 @@
       </p:sp>
       <p:sp>
         <p:nvSpPr>
-          <p:cNvPr id="15" name="Oval 14"/>
+          <p:cNvPr id="17" name="Oval 16"/>
           <p:cNvSpPr/>
           <p:nvPr/>
         </p:nvSpPr>
@@ -13793,7 +15055,7 @@
       </p:sp>
       <p:sp>
         <p:nvSpPr>
-          <p:cNvPr id="16" name="TextBox 15"/>
+          <p:cNvPr id="18" name="TextBox 17"/>
           <p:cNvSpPr txBox="1"/>
           <p:nvPr/>
         </p:nvSpPr>
@@ -13827,7 +15089,7 @@
       </p:sp>
       <p:sp>
         <p:nvSpPr>
-          <p:cNvPr id="17" name="Oval 16"/>
+          <p:cNvPr id="19" name="Oval 18"/>
           <p:cNvSpPr/>
           <p:nvPr/>
         </p:nvSpPr>
@@ -13880,7 +15142,7 @@
       </p:sp>
       <p:sp>
         <p:nvSpPr>
-          <p:cNvPr id="18" name="TextBox 17"/>
+          <p:cNvPr id="20" name="TextBox 19"/>
           <p:cNvSpPr txBox="1"/>
           <p:nvPr/>
         </p:nvSpPr>
@@ -13914,7 +15176,7 @@
       </p:sp>
       <p:sp>
         <p:nvSpPr>
-          <p:cNvPr id="19" name="Oval 18"/>
+          <p:cNvPr id="21" name="Oval 20"/>
           <p:cNvSpPr/>
           <p:nvPr/>
         </p:nvSpPr>
@@ -13967,7 +15229,7 @@
       </p:sp>
       <p:sp>
         <p:nvSpPr>
-          <p:cNvPr id="20" name="TextBox 19"/>
+          <p:cNvPr id="22" name="TextBox 21"/>
           <p:cNvSpPr txBox="1"/>
           <p:nvPr/>
         </p:nvSpPr>
@@ -14001,7 +15263,7 @@
       </p:sp>
       <p:sp>
         <p:nvSpPr>
-          <p:cNvPr id="21" name="Rounded Rectangle 20"/>
+          <p:cNvPr id="23" name="Rounded Rectangle 22"/>
           <p:cNvSpPr/>
           <p:nvPr/>
         </p:nvSpPr>
@@ -14057,7 +15319,7 @@
       </p:sp>
       <p:sp>
         <p:nvSpPr>
-          <p:cNvPr id="22" name="Rounded Rectangle 21"/>
+          <p:cNvPr id="24" name="Rounded Rectangle 23"/>
           <p:cNvSpPr/>
           <p:nvPr/>
         </p:nvSpPr>
@@ -14105,7 +15367,7 @@
       </p:sp>
       <p:sp>
         <p:nvSpPr>
-          <p:cNvPr id="23" name="TextBox 22"/>
+          <p:cNvPr id="25" name="TextBox 24"/>
           <p:cNvSpPr txBox="1"/>
           <p:nvPr/>
         </p:nvSpPr>
@@ -14563,7 +15825,111 @@
       </p:pic>
       <p:sp>
         <p:nvSpPr>
-          <p:cNvPr id="11" name="TextBox 10"/>
+          <p:cNvPr id="11" name="Rounded Rectangle 10"/>
+          <p:cNvSpPr/>
+          <p:nvPr/>
+        </p:nvSpPr>
+        <p:spPr>
+          <a:xfrm>
+            <a:off x="411479" y="1444752"/>
+            <a:ext cx="11368735" cy="4800600"/>
+          </a:xfrm>
+          <a:prstGeom prst="roundRect">
+            <a:avLst>
+              <a:gd name="adj" fmla="val 4000"/>
+            </a:avLst>
+          </a:prstGeom>
+          <a:solidFill>
+            <a:srgbClr val="FFFFFF">
+              <a:alpha val="84000"/>
+            </a:srgbClr>
+          </a:solidFill>
+          <a:ln w="19050">
+            <a:solidFill>
+              <a:srgbClr val="FFFFFF"/>
+            </a:solidFill>
+          </a:ln>
+          <a:effectLst>
+            <a:outerShdw blurRad="203200" dist="50800" dir="5400000" algn="t" rotWithShape="0">
+              <a:srgbClr val="1A2340">
+                <a:alpha val="20000"/>
+              </a:srgbClr>
+            </a:outerShdw>
+          </a:effectLst>
+        </p:spPr>
+        <p:style>
+          <a:lnRef idx="1">
+            <a:schemeClr val="accent1"/>
+          </a:lnRef>
+          <a:fillRef idx="3">
+            <a:schemeClr val="accent1"/>
+          </a:fillRef>
+          <a:effectRef idx="2">
+            <a:schemeClr val="accent1"/>
+          </a:effectRef>
+          <a:fontRef idx="minor">
+            <a:schemeClr val="lt1"/>
+          </a:fontRef>
+        </p:style>
+        <p:txBody>
+          <a:bodyPr rtlCol="0" anchor="ctr"/>
+          <a:lstStyle/>
+          <a:p>
+            <a:pPr algn="ctr"/>
+          </a:p>
+        </p:txBody>
+      </p:sp>
+      <p:sp>
+        <p:nvSpPr>
+          <p:cNvPr id="12" name="Rounded Rectangle 11"/>
+          <p:cNvSpPr/>
+          <p:nvPr/>
+        </p:nvSpPr>
+        <p:spPr>
+          <a:xfrm>
+            <a:off x="731519" y="1508760"/>
+            <a:ext cx="10728655" cy="32004"/>
+          </a:xfrm>
+          <a:prstGeom prst="roundRect">
+            <a:avLst>
+              <a:gd name="adj" fmla="val 50000"/>
+            </a:avLst>
+          </a:prstGeom>
+          <a:solidFill>
+            <a:srgbClr val="FFFFFF">
+              <a:alpha val="85000"/>
+            </a:srgbClr>
+          </a:solidFill>
+          <a:ln>
+            <a:noFill/>
+          </a:ln>
+          <a:effectLst/>
+        </p:spPr>
+        <p:style>
+          <a:lnRef idx="1">
+            <a:schemeClr val="accent1"/>
+          </a:lnRef>
+          <a:fillRef idx="3">
+            <a:schemeClr val="accent1"/>
+          </a:fillRef>
+          <a:effectRef idx="2">
+            <a:schemeClr val="accent1"/>
+          </a:effectRef>
+          <a:fontRef idx="minor">
+            <a:schemeClr val="lt1"/>
+          </a:fontRef>
+        </p:style>
+        <p:txBody>
+          <a:bodyPr rtlCol="0" anchor="ctr"/>
+          <a:lstStyle/>
+          <a:p>
+            <a:pPr algn="ctr"/>
+          </a:p>
+        </p:txBody>
+      </p:sp>
+      <p:sp>
+        <p:nvSpPr>
+          <p:cNvPr id="13" name="TextBox 12"/>
           <p:cNvSpPr txBox="1"/>
           <p:nvPr/>
         </p:nvSpPr>
@@ -14597,7 +15963,7 @@
       </p:sp>
       <p:sp>
         <p:nvSpPr>
-          <p:cNvPr id="12" name="Rounded Rectangle 11"/>
+          <p:cNvPr id="14" name="Rounded Rectangle 13"/>
           <p:cNvSpPr/>
           <p:nvPr/>
         </p:nvSpPr>
@@ -14653,7 +16019,7 @@
       </p:sp>
       <p:sp>
         <p:nvSpPr>
-          <p:cNvPr id="13" name="Oval 12"/>
+          <p:cNvPr id="15" name="Oval 14"/>
           <p:cNvSpPr/>
           <p:nvPr/>
         </p:nvSpPr>
@@ -14706,7 +16072,7 @@
       </p:sp>
       <p:sp>
         <p:nvSpPr>
-          <p:cNvPr id="14" name="TextBox 13"/>
+          <p:cNvPr id="16" name="TextBox 15"/>
           <p:cNvSpPr txBox="1"/>
           <p:nvPr/>
         </p:nvSpPr>
@@ -14740,7 +16106,7 @@
       </p:sp>
       <p:sp>
         <p:nvSpPr>
-          <p:cNvPr id="15" name="Rounded Rectangle 14"/>
+          <p:cNvPr id="17" name="Rounded Rectangle 16"/>
           <p:cNvSpPr/>
           <p:nvPr/>
         </p:nvSpPr>
@@ -14799,7 +16165,7 @@
       </p:sp>
       <p:sp>
         <p:nvSpPr>
-          <p:cNvPr id="16" name="Oval 15"/>
+          <p:cNvPr id="18" name="Oval 17"/>
           <p:cNvSpPr/>
           <p:nvPr/>
         </p:nvSpPr>
@@ -14852,7 +16218,7 @@
       </p:sp>
       <p:sp>
         <p:nvSpPr>
-          <p:cNvPr id="17" name="TextBox 16"/>
+          <p:cNvPr id="19" name="TextBox 18"/>
           <p:cNvSpPr txBox="1"/>
           <p:nvPr/>
         </p:nvSpPr>
@@ -14886,7 +16252,7 @@
       </p:sp>
       <p:sp>
         <p:nvSpPr>
-          <p:cNvPr id="18" name="Rounded Rectangle 17"/>
+          <p:cNvPr id="20" name="Rounded Rectangle 19"/>
           <p:cNvSpPr/>
           <p:nvPr/>
         </p:nvSpPr>
@@ -14942,7 +16308,7 @@
       </p:sp>
       <p:sp>
         <p:nvSpPr>
-          <p:cNvPr id="19" name="Oval 18"/>
+          <p:cNvPr id="21" name="Oval 20"/>
           <p:cNvSpPr/>
           <p:nvPr/>
         </p:nvSpPr>
@@ -14995,7 +16361,7 @@
       </p:sp>
       <p:sp>
         <p:nvSpPr>
-          <p:cNvPr id="20" name="TextBox 19"/>
+          <p:cNvPr id="22" name="TextBox 21"/>
           <p:cNvSpPr txBox="1"/>
           <p:nvPr/>
         </p:nvSpPr>
@@ -15029,7 +16395,7 @@
       </p:sp>
       <p:sp>
         <p:nvSpPr>
-          <p:cNvPr id="21" name="Rounded Rectangle 20"/>
+          <p:cNvPr id="23" name="Rounded Rectangle 22"/>
           <p:cNvSpPr/>
           <p:nvPr/>
         </p:nvSpPr>
@@ -15085,7 +16451,7 @@
       </p:sp>
       <p:sp>
         <p:nvSpPr>
-          <p:cNvPr id="22" name="Oval 21"/>
+          <p:cNvPr id="24" name="Oval 23"/>
           <p:cNvSpPr/>
           <p:nvPr/>
         </p:nvSpPr>
@@ -15138,7 +16504,7 @@
       </p:sp>
       <p:sp>
         <p:nvSpPr>
-          <p:cNvPr id="23" name="TextBox 22"/>
+          <p:cNvPr id="25" name="TextBox 24"/>
           <p:cNvSpPr txBox="1"/>
           <p:nvPr/>
         </p:nvSpPr>
@@ -15172,7 +16538,7 @@
       </p:sp>
       <p:sp>
         <p:nvSpPr>
-          <p:cNvPr id="24" name="TextBox 23"/>
+          <p:cNvPr id="26" name="TextBox 25"/>
           <p:cNvSpPr txBox="1"/>
           <p:nvPr/>
         </p:nvSpPr>
@@ -15596,7 +16962,111 @@
       </p:pic>
       <p:sp>
         <p:nvSpPr>
-          <p:cNvPr id="11" name="TextBox 10"/>
+          <p:cNvPr id="11" name="Rounded Rectangle 10"/>
+          <p:cNvSpPr/>
+          <p:nvPr/>
+        </p:nvSpPr>
+        <p:spPr>
+          <a:xfrm>
+            <a:off x="411479" y="1444752"/>
+            <a:ext cx="11368735" cy="4800600"/>
+          </a:xfrm>
+          <a:prstGeom prst="roundRect">
+            <a:avLst>
+              <a:gd name="adj" fmla="val 4000"/>
+            </a:avLst>
+          </a:prstGeom>
+          <a:solidFill>
+            <a:srgbClr val="FFFFFF">
+              <a:alpha val="84000"/>
+            </a:srgbClr>
+          </a:solidFill>
+          <a:ln w="19050">
+            <a:solidFill>
+              <a:srgbClr val="FFFFFF"/>
+            </a:solidFill>
+          </a:ln>
+          <a:effectLst>
+            <a:outerShdw blurRad="203200" dist="50800" dir="5400000" algn="t" rotWithShape="0">
+              <a:srgbClr val="1A2340">
+                <a:alpha val="20000"/>
+              </a:srgbClr>
+            </a:outerShdw>
+          </a:effectLst>
+        </p:spPr>
+        <p:style>
+          <a:lnRef idx="1">
+            <a:schemeClr val="accent1"/>
+          </a:lnRef>
+          <a:fillRef idx="3">
+            <a:schemeClr val="accent1"/>
+          </a:fillRef>
+          <a:effectRef idx="2">
+            <a:schemeClr val="accent1"/>
+          </a:effectRef>
+          <a:fontRef idx="minor">
+            <a:schemeClr val="lt1"/>
+          </a:fontRef>
+        </p:style>
+        <p:txBody>
+          <a:bodyPr rtlCol="0" anchor="ctr"/>
+          <a:lstStyle/>
+          <a:p>
+            <a:pPr algn="ctr"/>
+          </a:p>
+        </p:txBody>
+      </p:sp>
+      <p:sp>
+        <p:nvSpPr>
+          <p:cNvPr id="12" name="Rounded Rectangle 11"/>
+          <p:cNvSpPr/>
+          <p:nvPr/>
+        </p:nvSpPr>
+        <p:spPr>
+          <a:xfrm>
+            <a:off x="731519" y="1508760"/>
+            <a:ext cx="10728655" cy="32004"/>
+          </a:xfrm>
+          <a:prstGeom prst="roundRect">
+            <a:avLst>
+              <a:gd name="adj" fmla="val 50000"/>
+            </a:avLst>
+          </a:prstGeom>
+          <a:solidFill>
+            <a:srgbClr val="FFFFFF">
+              <a:alpha val="85000"/>
+            </a:srgbClr>
+          </a:solidFill>
+          <a:ln>
+            <a:noFill/>
+          </a:ln>
+          <a:effectLst/>
+        </p:spPr>
+        <p:style>
+          <a:lnRef idx="1">
+            <a:schemeClr val="accent1"/>
+          </a:lnRef>
+          <a:fillRef idx="3">
+            <a:schemeClr val="accent1"/>
+          </a:fillRef>
+          <a:effectRef idx="2">
+            <a:schemeClr val="accent1"/>
+          </a:effectRef>
+          <a:fontRef idx="minor">
+            <a:schemeClr val="lt1"/>
+          </a:fontRef>
+        </p:style>
+        <p:txBody>
+          <a:bodyPr rtlCol="0" anchor="ctr"/>
+          <a:lstStyle/>
+          <a:p>
+            <a:pPr algn="ctr"/>
+          </a:p>
+        </p:txBody>
+      </p:sp>
+      <p:sp>
+        <p:nvSpPr>
+          <p:cNvPr id="13" name="TextBox 12"/>
           <p:cNvSpPr txBox="1"/>
           <p:nvPr/>
         </p:nvSpPr>
@@ -15630,7 +17100,7 @@
       </p:sp>
       <p:sp>
         <p:nvSpPr>
-          <p:cNvPr id="12" name="Rounded Rectangle 11"/>
+          <p:cNvPr id="14" name="Rounded Rectangle 13"/>
           <p:cNvSpPr/>
           <p:nvPr/>
         </p:nvSpPr>
@@ -15686,7 +17156,7 @@
       </p:sp>
       <p:sp>
         <p:nvSpPr>
-          <p:cNvPr id="13" name="Oval 12"/>
+          <p:cNvPr id="15" name="Oval 14"/>
           <p:cNvSpPr/>
           <p:nvPr/>
         </p:nvSpPr>
@@ -15739,7 +17209,7 @@
       </p:sp>
       <p:sp>
         <p:nvSpPr>
-          <p:cNvPr id="14" name="TextBox 13"/>
+          <p:cNvPr id="16" name="TextBox 15"/>
           <p:cNvSpPr txBox="1"/>
           <p:nvPr/>
         </p:nvSpPr>
@@ -15773,7 +17243,7 @@
       </p:sp>
       <p:sp>
         <p:nvSpPr>
-          <p:cNvPr id="15" name="Rounded Rectangle 14"/>
+          <p:cNvPr id="17" name="Rounded Rectangle 16"/>
           <p:cNvSpPr/>
           <p:nvPr/>
         </p:nvSpPr>
@@ -15829,7 +17299,7 @@
       </p:sp>
       <p:sp>
         <p:nvSpPr>
-          <p:cNvPr id="16" name="Oval 15"/>
+          <p:cNvPr id="18" name="Oval 17"/>
           <p:cNvSpPr/>
           <p:nvPr/>
         </p:nvSpPr>
@@ -15882,7 +17352,7 @@
       </p:sp>
       <p:sp>
         <p:nvSpPr>
-          <p:cNvPr id="17" name="TextBox 16"/>
+          <p:cNvPr id="19" name="TextBox 18"/>
           <p:cNvSpPr txBox="1"/>
           <p:nvPr/>
         </p:nvSpPr>
@@ -15916,7 +17386,7 @@
       </p:sp>
       <p:sp>
         <p:nvSpPr>
-          <p:cNvPr id="18" name="Rounded Rectangle 17"/>
+          <p:cNvPr id="20" name="Rounded Rectangle 19"/>
           <p:cNvSpPr/>
           <p:nvPr/>
         </p:nvSpPr>
@@ -15972,7 +17442,7 @@
       </p:sp>
       <p:sp>
         <p:nvSpPr>
-          <p:cNvPr id="19" name="Oval 18"/>
+          <p:cNvPr id="21" name="Oval 20"/>
           <p:cNvSpPr/>
           <p:nvPr/>
         </p:nvSpPr>
@@ -16025,7 +17495,7 @@
       </p:sp>
       <p:sp>
         <p:nvSpPr>
-          <p:cNvPr id="20" name="TextBox 19"/>
+          <p:cNvPr id="22" name="TextBox 21"/>
           <p:cNvSpPr txBox="1"/>
           <p:nvPr/>
         </p:nvSpPr>
@@ -16059,7 +17529,7 @@
       </p:sp>
       <p:sp>
         <p:nvSpPr>
-          <p:cNvPr id="21" name="Rounded Rectangle 20"/>
+          <p:cNvPr id="23" name="Rounded Rectangle 22"/>
           <p:cNvSpPr/>
           <p:nvPr/>
         </p:nvSpPr>
@@ -16115,7 +17585,7 @@
       </p:sp>
       <p:sp>
         <p:nvSpPr>
-          <p:cNvPr id="22" name="Oval 21"/>
+          <p:cNvPr id="24" name="Oval 23"/>
           <p:cNvSpPr/>
           <p:nvPr/>
         </p:nvSpPr>
@@ -16168,7 +17638,7 @@
       </p:sp>
       <p:sp>
         <p:nvSpPr>
-          <p:cNvPr id="23" name="TextBox 22"/>
+          <p:cNvPr id="25" name="TextBox 24"/>
           <p:cNvSpPr txBox="1"/>
           <p:nvPr/>
         </p:nvSpPr>
@@ -16583,7 +18053,111 @@
       </p:pic>
       <p:sp>
         <p:nvSpPr>
-          <p:cNvPr id="11" name="TextBox 10"/>
+          <p:cNvPr id="11" name="Rounded Rectangle 10"/>
+          <p:cNvSpPr/>
+          <p:nvPr/>
+        </p:nvSpPr>
+        <p:spPr>
+          <a:xfrm>
+            <a:off x="411479" y="1444752"/>
+            <a:ext cx="11368735" cy="4800600"/>
+          </a:xfrm>
+          <a:prstGeom prst="roundRect">
+            <a:avLst>
+              <a:gd name="adj" fmla="val 4000"/>
+            </a:avLst>
+          </a:prstGeom>
+          <a:solidFill>
+            <a:srgbClr val="FFFFFF">
+              <a:alpha val="84000"/>
+            </a:srgbClr>
+          </a:solidFill>
+          <a:ln w="19050">
+            <a:solidFill>
+              <a:srgbClr val="FFFFFF"/>
+            </a:solidFill>
+          </a:ln>
+          <a:effectLst>
+            <a:outerShdw blurRad="203200" dist="50800" dir="5400000" algn="t" rotWithShape="0">
+              <a:srgbClr val="1A2340">
+                <a:alpha val="20000"/>
+              </a:srgbClr>
+            </a:outerShdw>
+          </a:effectLst>
+        </p:spPr>
+        <p:style>
+          <a:lnRef idx="1">
+            <a:schemeClr val="accent1"/>
+          </a:lnRef>
+          <a:fillRef idx="3">
+            <a:schemeClr val="accent1"/>
+          </a:fillRef>
+          <a:effectRef idx="2">
+            <a:schemeClr val="accent1"/>
+          </a:effectRef>
+          <a:fontRef idx="minor">
+            <a:schemeClr val="lt1"/>
+          </a:fontRef>
+        </p:style>
+        <p:txBody>
+          <a:bodyPr rtlCol="0" anchor="ctr"/>
+          <a:lstStyle/>
+          <a:p>
+            <a:pPr algn="ctr"/>
+          </a:p>
+        </p:txBody>
+      </p:sp>
+      <p:sp>
+        <p:nvSpPr>
+          <p:cNvPr id="12" name="Rounded Rectangle 11"/>
+          <p:cNvSpPr/>
+          <p:nvPr/>
+        </p:nvSpPr>
+        <p:spPr>
+          <a:xfrm>
+            <a:off x="731519" y="1508760"/>
+            <a:ext cx="10728655" cy="32004"/>
+          </a:xfrm>
+          <a:prstGeom prst="roundRect">
+            <a:avLst>
+              <a:gd name="adj" fmla="val 50000"/>
+            </a:avLst>
+          </a:prstGeom>
+          <a:solidFill>
+            <a:srgbClr val="FFFFFF">
+              <a:alpha val="85000"/>
+            </a:srgbClr>
+          </a:solidFill>
+          <a:ln>
+            <a:noFill/>
+          </a:ln>
+          <a:effectLst/>
+        </p:spPr>
+        <p:style>
+          <a:lnRef idx="1">
+            <a:schemeClr val="accent1"/>
+          </a:lnRef>
+          <a:fillRef idx="3">
+            <a:schemeClr val="accent1"/>
+          </a:fillRef>
+          <a:effectRef idx="2">
+            <a:schemeClr val="accent1"/>
+          </a:effectRef>
+          <a:fontRef idx="minor">
+            <a:schemeClr val="lt1"/>
+          </a:fontRef>
+        </p:style>
+        <p:txBody>
+          <a:bodyPr rtlCol="0" anchor="ctr"/>
+          <a:lstStyle/>
+          <a:p>
+            <a:pPr algn="ctr"/>
+          </a:p>
+        </p:txBody>
+      </p:sp>
+      <p:sp>
+        <p:nvSpPr>
+          <p:cNvPr id="13" name="TextBox 12"/>
           <p:cNvSpPr txBox="1"/>
           <p:nvPr/>
         </p:nvSpPr>
@@ -16617,7 +18191,7 @@
       </p:sp>
       <p:sp>
         <p:nvSpPr>
-          <p:cNvPr id="12" name="Rounded Rectangle 11"/>
+          <p:cNvPr id="14" name="Rounded Rectangle 13"/>
           <p:cNvSpPr/>
           <p:nvPr/>
         </p:nvSpPr>
@@ -16673,7 +18247,7 @@
       </p:sp>
       <p:sp>
         <p:nvSpPr>
-          <p:cNvPr id="13" name="Oval 12"/>
+          <p:cNvPr id="15" name="Oval 14"/>
           <p:cNvSpPr/>
           <p:nvPr/>
         </p:nvSpPr>
@@ -16726,7 +18300,7 @@
       </p:sp>
       <p:sp>
         <p:nvSpPr>
-          <p:cNvPr id="14" name="TextBox 13"/>
+          <p:cNvPr id="16" name="TextBox 15"/>
           <p:cNvSpPr txBox="1"/>
           <p:nvPr/>
         </p:nvSpPr>
@@ -16760,7 +18334,7 @@
       </p:sp>
       <p:sp>
         <p:nvSpPr>
-          <p:cNvPr id="15" name="Rounded Rectangle 14"/>
+          <p:cNvPr id="17" name="Rounded Rectangle 16"/>
           <p:cNvSpPr/>
           <p:nvPr/>
         </p:nvSpPr>
@@ -16816,7 +18390,7 @@
       </p:sp>
       <p:sp>
         <p:nvSpPr>
-          <p:cNvPr id="16" name="Oval 15"/>
+          <p:cNvPr id="18" name="Oval 17"/>
           <p:cNvSpPr/>
           <p:nvPr/>
         </p:nvSpPr>
@@ -16869,7 +18443,7 @@
       </p:sp>
       <p:sp>
         <p:nvSpPr>
-          <p:cNvPr id="17" name="TextBox 16"/>
+          <p:cNvPr id="19" name="TextBox 18"/>
           <p:cNvSpPr txBox="1"/>
           <p:nvPr/>
         </p:nvSpPr>
@@ -16903,7 +18477,7 @@
       </p:sp>
       <p:sp>
         <p:nvSpPr>
-          <p:cNvPr id="18" name="Rounded Rectangle 17"/>
+          <p:cNvPr id="20" name="Rounded Rectangle 19"/>
           <p:cNvSpPr/>
           <p:nvPr/>
         </p:nvSpPr>
@@ -16959,7 +18533,7 @@
       </p:sp>
       <p:sp>
         <p:nvSpPr>
-          <p:cNvPr id="19" name="Oval 18"/>
+          <p:cNvPr id="21" name="Oval 20"/>
           <p:cNvSpPr/>
           <p:nvPr/>
         </p:nvSpPr>
@@ -17012,7 +18586,7 @@
       </p:sp>
       <p:sp>
         <p:nvSpPr>
-          <p:cNvPr id="20" name="TextBox 19"/>
+          <p:cNvPr id="22" name="TextBox 21"/>
           <p:cNvSpPr txBox="1"/>
           <p:nvPr/>
         </p:nvSpPr>
@@ -17046,7 +18620,7 @@
       </p:sp>
       <p:sp>
         <p:nvSpPr>
-          <p:cNvPr id="21" name="Rounded Rectangle 20"/>
+          <p:cNvPr id="23" name="Rounded Rectangle 22"/>
           <p:cNvSpPr/>
           <p:nvPr/>
         </p:nvSpPr>
@@ -17105,7 +18679,7 @@
       </p:sp>
       <p:sp>
         <p:nvSpPr>
-          <p:cNvPr id="22" name="Oval 21"/>
+          <p:cNvPr id="24" name="Oval 23"/>
           <p:cNvSpPr/>
           <p:nvPr/>
         </p:nvSpPr>
@@ -17158,7 +18732,7 @@
       </p:sp>
       <p:sp>
         <p:nvSpPr>
-          <p:cNvPr id="23" name="TextBox 22"/>
+          <p:cNvPr id="25" name="TextBox 24"/>
           <p:cNvSpPr txBox="1"/>
           <p:nvPr/>
         </p:nvSpPr>
@@ -17192,7 +18766,7 @@
       </p:sp>
       <p:sp>
         <p:nvSpPr>
-          <p:cNvPr id="24" name="TextBox 23"/>
+          <p:cNvPr id="26" name="TextBox 25"/>
           <p:cNvSpPr txBox="1"/>
           <p:nvPr/>
         </p:nvSpPr>
@@ -17616,7 +19190,111 @@
       </p:pic>
       <p:sp>
         <p:nvSpPr>
-          <p:cNvPr id="11" name="TextBox 10"/>
+          <p:cNvPr id="11" name="Rounded Rectangle 10"/>
+          <p:cNvSpPr/>
+          <p:nvPr/>
+        </p:nvSpPr>
+        <p:spPr>
+          <a:xfrm>
+            <a:off x="411479" y="1444752"/>
+            <a:ext cx="11368735" cy="4800600"/>
+          </a:xfrm>
+          <a:prstGeom prst="roundRect">
+            <a:avLst>
+              <a:gd name="adj" fmla="val 4000"/>
+            </a:avLst>
+          </a:prstGeom>
+          <a:solidFill>
+            <a:srgbClr val="FFFFFF">
+              <a:alpha val="84000"/>
+            </a:srgbClr>
+          </a:solidFill>
+          <a:ln w="19050">
+            <a:solidFill>
+              <a:srgbClr val="FFFFFF"/>
+            </a:solidFill>
+          </a:ln>
+          <a:effectLst>
+            <a:outerShdw blurRad="203200" dist="50800" dir="5400000" algn="t" rotWithShape="0">
+              <a:srgbClr val="1A2340">
+                <a:alpha val="20000"/>
+              </a:srgbClr>
+            </a:outerShdw>
+          </a:effectLst>
+        </p:spPr>
+        <p:style>
+          <a:lnRef idx="1">
+            <a:schemeClr val="accent1"/>
+          </a:lnRef>
+          <a:fillRef idx="3">
+            <a:schemeClr val="accent1"/>
+          </a:fillRef>
+          <a:effectRef idx="2">
+            <a:schemeClr val="accent1"/>
+          </a:effectRef>
+          <a:fontRef idx="minor">
+            <a:schemeClr val="lt1"/>
+          </a:fontRef>
+        </p:style>
+        <p:txBody>
+          <a:bodyPr rtlCol="0" anchor="ctr"/>
+          <a:lstStyle/>
+          <a:p>
+            <a:pPr algn="ctr"/>
+          </a:p>
+        </p:txBody>
+      </p:sp>
+      <p:sp>
+        <p:nvSpPr>
+          <p:cNvPr id="12" name="Rounded Rectangle 11"/>
+          <p:cNvSpPr/>
+          <p:nvPr/>
+        </p:nvSpPr>
+        <p:spPr>
+          <a:xfrm>
+            <a:off x="731519" y="1508760"/>
+            <a:ext cx="10728655" cy="32004"/>
+          </a:xfrm>
+          <a:prstGeom prst="roundRect">
+            <a:avLst>
+              <a:gd name="adj" fmla="val 50000"/>
+            </a:avLst>
+          </a:prstGeom>
+          <a:solidFill>
+            <a:srgbClr val="FFFFFF">
+              <a:alpha val="85000"/>
+            </a:srgbClr>
+          </a:solidFill>
+          <a:ln>
+            <a:noFill/>
+          </a:ln>
+          <a:effectLst/>
+        </p:spPr>
+        <p:style>
+          <a:lnRef idx="1">
+            <a:schemeClr val="accent1"/>
+          </a:lnRef>
+          <a:fillRef idx="3">
+            <a:schemeClr val="accent1"/>
+          </a:fillRef>
+          <a:effectRef idx="2">
+            <a:schemeClr val="accent1"/>
+          </a:effectRef>
+          <a:fontRef idx="minor">
+            <a:schemeClr val="lt1"/>
+          </a:fontRef>
+        </p:style>
+        <p:txBody>
+          <a:bodyPr rtlCol="0" anchor="ctr"/>
+          <a:lstStyle/>
+          <a:p>
+            <a:pPr algn="ctr"/>
+          </a:p>
+        </p:txBody>
+      </p:sp>
+      <p:sp>
+        <p:nvSpPr>
+          <p:cNvPr id="13" name="TextBox 12"/>
           <p:cNvSpPr txBox="1"/>
           <p:nvPr/>
         </p:nvSpPr>
@@ -17650,7 +19328,7 @@
       </p:sp>
       <p:sp>
         <p:nvSpPr>
-          <p:cNvPr id="12" name="Rounded Rectangle 11"/>
+          <p:cNvPr id="14" name="Rounded Rectangle 13"/>
           <p:cNvSpPr/>
           <p:nvPr/>
         </p:nvSpPr>
@@ -17706,7 +19384,7 @@
       </p:sp>
       <p:sp>
         <p:nvSpPr>
-          <p:cNvPr id="13" name="Oval 12"/>
+          <p:cNvPr id="15" name="Oval 14"/>
           <p:cNvSpPr/>
           <p:nvPr/>
         </p:nvSpPr>
@@ -17759,7 +19437,7 @@
       </p:sp>
       <p:sp>
         <p:nvSpPr>
-          <p:cNvPr id="14" name="TextBox 13"/>
+          <p:cNvPr id="16" name="TextBox 15"/>
           <p:cNvSpPr txBox="1"/>
           <p:nvPr/>
         </p:nvSpPr>
@@ -17793,7 +19471,7 @@
       </p:sp>
       <p:sp>
         <p:nvSpPr>
-          <p:cNvPr id="15" name="Rounded Rectangle 14"/>
+          <p:cNvPr id="17" name="Rounded Rectangle 16"/>
           <p:cNvSpPr/>
           <p:nvPr/>
         </p:nvSpPr>
@@ -17849,7 +19527,7 @@
       </p:sp>
       <p:sp>
         <p:nvSpPr>
-          <p:cNvPr id="16" name="Oval 15"/>
+          <p:cNvPr id="18" name="Oval 17"/>
           <p:cNvSpPr/>
           <p:nvPr/>
         </p:nvSpPr>
@@ -17902,7 +19580,7 @@
       </p:sp>
       <p:sp>
         <p:nvSpPr>
-          <p:cNvPr id="17" name="TextBox 16"/>
+          <p:cNvPr id="19" name="TextBox 18"/>
           <p:cNvSpPr txBox="1"/>
           <p:nvPr/>
         </p:nvSpPr>
@@ -17936,7 +19614,7 @@
       </p:sp>
       <p:sp>
         <p:nvSpPr>
-          <p:cNvPr id="18" name="Rounded Rectangle 17"/>
+          <p:cNvPr id="20" name="Rounded Rectangle 19"/>
           <p:cNvSpPr/>
           <p:nvPr/>
         </p:nvSpPr>
@@ -17992,7 +19670,7 @@
       </p:sp>
       <p:sp>
         <p:nvSpPr>
-          <p:cNvPr id="19" name="Oval 18"/>
+          <p:cNvPr id="21" name="Oval 20"/>
           <p:cNvSpPr/>
           <p:nvPr/>
         </p:nvSpPr>
@@ -18045,7 +19723,7 @@
       </p:sp>
       <p:sp>
         <p:nvSpPr>
-          <p:cNvPr id="20" name="TextBox 19"/>
+          <p:cNvPr id="22" name="TextBox 21"/>
           <p:cNvSpPr txBox="1"/>
           <p:nvPr/>
         </p:nvSpPr>
@@ -18079,7 +19757,7 @@
       </p:sp>
       <p:sp>
         <p:nvSpPr>
-          <p:cNvPr id="21" name="Rounded Rectangle 20"/>
+          <p:cNvPr id="23" name="Rounded Rectangle 22"/>
           <p:cNvSpPr/>
           <p:nvPr/>
         </p:nvSpPr>
@@ -18135,7 +19813,7 @@
       </p:sp>
       <p:sp>
         <p:nvSpPr>
-          <p:cNvPr id="22" name="Oval 21"/>
+          <p:cNvPr id="24" name="Oval 23"/>
           <p:cNvSpPr/>
           <p:nvPr/>
         </p:nvSpPr>
@@ -18188,7 +19866,7 @@
       </p:sp>
       <p:sp>
         <p:nvSpPr>
-          <p:cNvPr id="23" name="TextBox 22"/>
+          <p:cNvPr id="25" name="TextBox 24"/>
           <p:cNvSpPr txBox="1"/>
           <p:nvPr/>
         </p:nvSpPr>
@@ -18603,7 +20281,111 @@
       </p:pic>
       <p:sp>
         <p:nvSpPr>
-          <p:cNvPr id="11" name="TextBox 10"/>
+          <p:cNvPr id="11" name="Rounded Rectangle 10"/>
+          <p:cNvSpPr/>
+          <p:nvPr/>
+        </p:nvSpPr>
+        <p:spPr>
+          <a:xfrm>
+            <a:off x="411479" y="1444752"/>
+            <a:ext cx="11368735" cy="4800600"/>
+          </a:xfrm>
+          <a:prstGeom prst="roundRect">
+            <a:avLst>
+              <a:gd name="adj" fmla="val 4000"/>
+            </a:avLst>
+          </a:prstGeom>
+          <a:solidFill>
+            <a:srgbClr val="FFFFFF">
+              <a:alpha val="84000"/>
+            </a:srgbClr>
+          </a:solidFill>
+          <a:ln w="19050">
+            <a:solidFill>
+              <a:srgbClr val="FFFFFF"/>
+            </a:solidFill>
+          </a:ln>
+          <a:effectLst>
+            <a:outerShdw blurRad="203200" dist="50800" dir="5400000" algn="t" rotWithShape="0">
+              <a:srgbClr val="1A2340">
+                <a:alpha val="20000"/>
+              </a:srgbClr>
+            </a:outerShdw>
+          </a:effectLst>
+        </p:spPr>
+        <p:style>
+          <a:lnRef idx="1">
+            <a:schemeClr val="accent1"/>
+          </a:lnRef>
+          <a:fillRef idx="3">
+            <a:schemeClr val="accent1"/>
+          </a:fillRef>
+          <a:effectRef idx="2">
+            <a:schemeClr val="accent1"/>
+          </a:effectRef>
+          <a:fontRef idx="minor">
+            <a:schemeClr val="lt1"/>
+          </a:fontRef>
+        </p:style>
+        <p:txBody>
+          <a:bodyPr rtlCol="0" anchor="ctr"/>
+          <a:lstStyle/>
+          <a:p>
+            <a:pPr algn="ctr"/>
+          </a:p>
+        </p:txBody>
+      </p:sp>
+      <p:sp>
+        <p:nvSpPr>
+          <p:cNvPr id="12" name="Rounded Rectangle 11"/>
+          <p:cNvSpPr/>
+          <p:nvPr/>
+        </p:nvSpPr>
+        <p:spPr>
+          <a:xfrm>
+            <a:off x="731519" y="1508760"/>
+            <a:ext cx="10728655" cy="32004"/>
+          </a:xfrm>
+          <a:prstGeom prst="roundRect">
+            <a:avLst>
+              <a:gd name="adj" fmla="val 50000"/>
+            </a:avLst>
+          </a:prstGeom>
+          <a:solidFill>
+            <a:srgbClr val="FFFFFF">
+              <a:alpha val="85000"/>
+            </a:srgbClr>
+          </a:solidFill>
+          <a:ln>
+            <a:noFill/>
+          </a:ln>
+          <a:effectLst/>
+        </p:spPr>
+        <p:style>
+          <a:lnRef idx="1">
+            <a:schemeClr val="accent1"/>
+          </a:lnRef>
+          <a:fillRef idx="3">
+            <a:schemeClr val="accent1"/>
+          </a:fillRef>
+          <a:effectRef idx="2">
+            <a:schemeClr val="accent1"/>
+          </a:effectRef>
+          <a:fontRef idx="minor">
+            <a:schemeClr val="lt1"/>
+          </a:fontRef>
+        </p:style>
+        <p:txBody>
+          <a:bodyPr rtlCol="0" anchor="ctr"/>
+          <a:lstStyle/>
+          <a:p>
+            <a:pPr algn="ctr"/>
+          </a:p>
+        </p:txBody>
+      </p:sp>
+      <p:sp>
+        <p:nvSpPr>
+          <p:cNvPr id="13" name="TextBox 12"/>
           <p:cNvSpPr txBox="1"/>
           <p:nvPr/>
         </p:nvSpPr>
@@ -18637,7 +20419,7 @@
       </p:sp>
       <p:sp>
         <p:nvSpPr>
-          <p:cNvPr id="12" name="Rounded Rectangle 11"/>
+          <p:cNvPr id="14" name="Rounded Rectangle 13"/>
           <p:cNvSpPr/>
           <p:nvPr/>
         </p:nvSpPr>
@@ -18693,7 +20475,7 @@
       </p:sp>
       <p:sp>
         <p:nvSpPr>
-          <p:cNvPr id="13" name="Oval 12"/>
+          <p:cNvPr id="15" name="Oval 14"/>
           <p:cNvSpPr/>
           <p:nvPr/>
         </p:nvSpPr>
@@ -18746,7 +20528,7 @@
       </p:sp>
       <p:sp>
         <p:nvSpPr>
-          <p:cNvPr id="14" name="TextBox 13"/>
+          <p:cNvPr id="16" name="TextBox 15"/>
           <p:cNvSpPr txBox="1"/>
           <p:nvPr/>
         </p:nvSpPr>
@@ -18780,7 +20562,7 @@
       </p:sp>
       <p:sp>
         <p:nvSpPr>
-          <p:cNvPr id="15" name="Rounded Rectangle 14"/>
+          <p:cNvPr id="17" name="Rounded Rectangle 16"/>
           <p:cNvSpPr/>
           <p:nvPr/>
         </p:nvSpPr>
@@ -18839,7 +20621,7 @@
       </p:sp>
       <p:sp>
         <p:nvSpPr>
-          <p:cNvPr id="16" name="Oval 15"/>
+          <p:cNvPr id="18" name="Oval 17"/>
           <p:cNvSpPr/>
           <p:nvPr/>
         </p:nvSpPr>
@@ -18892,7 +20674,7 @@
       </p:sp>
       <p:sp>
         <p:nvSpPr>
-          <p:cNvPr id="17" name="TextBox 16"/>
+          <p:cNvPr id="19" name="TextBox 18"/>
           <p:cNvSpPr txBox="1"/>
           <p:nvPr/>
         </p:nvSpPr>
@@ -18926,7 +20708,7 @@
       </p:sp>
       <p:sp>
         <p:nvSpPr>
-          <p:cNvPr id="18" name="Rounded Rectangle 17"/>
+          <p:cNvPr id="20" name="Rounded Rectangle 19"/>
           <p:cNvSpPr/>
           <p:nvPr/>
         </p:nvSpPr>
@@ -18982,7 +20764,7 @@
       </p:sp>
       <p:sp>
         <p:nvSpPr>
-          <p:cNvPr id="19" name="Oval 18"/>
+          <p:cNvPr id="21" name="Oval 20"/>
           <p:cNvSpPr/>
           <p:nvPr/>
         </p:nvSpPr>
@@ -19035,7 +20817,7 @@
       </p:sp>
       <p:sp>
         <p:nvSpPr>
-          <p:cNvPr id="20" name="TextBox 19"/>
+          <p:cNvPr id="22" name="TextBox 21"/>
           <p:cNvSpPr txBox="1"/>
           <p:nvPr/>
         </p:nvSpPr>
@@ -19069,7 +20851,7 @@
       </p:sp>
       <p:sp>
         <p:nvSpPr>
-          <p:cNvPr id="21" name="Rounded Rectangle 20"/>
+          <p:cNvPr id="23" name="Rounded Rectangle 22"/>
           <p:cNvSpPr/>
           <p:nvPr/>
         </p:nvSpPr>
@@ -19125,7 +20907,7 @@
       </p:sp>
       <p:sp>
         <p:nvSpPr>
-          <p:cNvPr id="22" name="Oval 21"/>
+          <p:cNvPr id="24" name="Oval 23"/>
           <p:cNvSpPr/>
           <p:nvPr/>
         </p:nvSpPr>
@@ -19178,7 +20960,7 @@
       </p:sp>
       <p:sp>
         <p:nvSpPr>
-          <p:cNvPr id="23" name="TextBox 22"/>
+          <p:cNvPr id="25" name="TextBox 24"/>
           <p:cNvSpPr txBox="1"/>
           <p:nvPr/>
         </p:nvSpPr>
@@ -19212,7 +20994,7 @@
       </p:sp>
       <p:sp>
         <p:nvSpPr>
-          <p:cNvPr id="24" name="TextBox 23"/>
+          <p:cNvPr id="26" name="TextBox 25"/>
           <p:cNvSpPr txBox="1"/>
           <p:nvPr/>
         </p:nvSpPr>
@@ -20411,7 +22193,111 @@
       </p:pic>
       <p:sp>
         <p:nvSpPr>
-          <p:cNvPr id="11" name="Oval 10"/>
+          <p:cNvPr id="11" name="Rounded Rectangle 10"/>
+          <p:cNvSpPr/>
+          <p:nvPr/>
+        </p:nvSpPr>
+        <p:spPr>
+          <a:xfrm>
+            <a:off x="411479" y="1444752"/>
+            <a:ext cx="11368735" cy="4800600"/>
+          </a:xfrm>
+          <a:prstGeom prst="roundRect">
+            <a:avLst>
+              <a:gd name="adj" fmla="val 4000"/>
+            </a:avLst>
+          </a:prstGeom>
+          <a:solidFill>
+            <a:srgbClr val="FFFFFF">
+              <a:alpha val="84000"/>
+            </a:srgbClr>
+          </a:solidFill>
+          <a:ln w="19050">
+            <a:solidFill>
+              <a:srgbClr val="FFFFFF"/>
+            </a:solidFill>
+          </a:ln>
+          <a:effectLst>
+            <a:outerShdw blurRad="203200" dist="50800" dir="5400000" algn="t" rotWithShape="0">
+              <a:srgbClr val="1A2340">
+                <a:alpha val="20000"/>
+              </a:srgbClr>
+            </a:outerShdw>
+          </a:effectLst>
+        </p:spPr>
+        <p:style>
+          <a:lnRef idx="1">
+            <a:schemeClr val="accent1"/>
+          </a:lnRef>
+          <a:fillRef idx="3">
+            <a:schemeClr val="accent1"/>
+          </a:fillRef>
+          <a:effectRef idx="2">
+            <a:schemeClr val="accent1"/>
+          </a:effectRef>
+          <a:fontRef idx="minor">
+            <a:schemeClr val="lt1"/>
+          </a:fontRef>
+        </p:style>
+        <p:txBody>
+          <a:bodyPr rtlCol="0" anchor="ctr"/>
+          <a:lstStyle/>
+          <a:p>
+            <a:pPr algn="ctr"/>
+          </a:p>
+        </p:txBody>
+      </p:sp>
+      <p:sp>
+        <p:nvSpPr>
+          <p:cNvPr id="12" name="Rounded Rectangle 11"/>
+          <p:cNvSpPr/>
+          <p:nvPr/>
+        </p:nvSpPr>
+        <p:spPr>
+          <a:xfrm>
+            <a:off x="731519" y="1508760"/>
+            <a:ext cx="10728655" cy="32004"/>
+          </a:xfrm>
+          <a:prstGeom prst="roundRect">
+            <a:avLst>
+              <a:gd name="adj" fmla="val 50000"/>
+            </a:avLst>
+          </a:prstGeom>
+          <a:solidFill>
+            <a:srgbClr val="FFFFFF">
+              <a:alpha val="85000"/>
+            </a:srgbClr>
+          </a:solidFill>
+          <a:ln>
+            <a:noFill/>
+          </a:ln>
+          <a:effectLst/>
+        </p:spPr>
+        <p:style>
+          <a:lnRef idx="1">
+            <a:schemeClr val="accent1"/>
+          </a:lnRef>
+          <a:fillRef idx="3">
+            <a:schemeClr val="accent1"/>
+          </a:fillRef>
+          <a:effectRef idx="2">
+            <a:schemeClr val="accent1"/>
+          </a:effectRef>
+          <a:fontRef idx="minor">
+            <a:schemeClr val="lt1"/>
+          </a:fontRef>
+        </p:style>
+        <p:txBody>
+          <a:bodyPr rtlCol="0" anchor="ctr"/>
+          <a:lstStyle/>
+          <a:p>
+            <a:pPr algn="ctr"/>
+          </a:p>
+        </p:txBody>
+      </p:sp>
+      <p:sp>
+        <p:nvSpPr>
+          <p:cNvPr id="13" name="Oval 12"/>
           <p:cNvSpPr/>
           <p:nvPr/>
         </p:nvSpPr>
@@ -20464,7 +22350,7 @@
       </p:sp>
       <p:sp>
         <p:nvSpPr>
-          <p:cNvPr id="12" name="TextBox 11"/>
+          <p:cNvPr id="14" name="TextBox 13"/>
           <p:cNvSpPr txBox="1"/>
           <p:nvPr/>
         </p:nvSpPr>
@@ -20498,7 +22384,7 @@
       </p:sp>
       <p:sp>
         <p:nvSpPr>
-          <p:cNvPr id="13" name="Oval 12"/>
+          <p:cNvPr id="15" name="Oval 14"/>
           <p:cNvSpPr/>
           <p:nvPr/>
         </p:nvSpPr>
@@ -20551,7 +22437,7 @@
       </p:sp>
       <p:sp>
         <p:nvSpPr>
-          <p:cNvPr id="14" name="TextBox 13"/>
+          <p:cNvPr id="16" name="TextBox 15"/>
           <p:cNvSpPr txBox="1"/>
           <p:nvPr/>
         </p:nvSpPr>
@@ -20585,7 +22471,7 @@
       </p:sp>
       <p:sp>
         <p:nvSpPr>
-          <p:cNvPr id="15" name="Oval 14"/>
+          <p:cNvPr id="17" name="Oval 16"/>
           <p:cNvSpPr/>
           <p:nvPr/>
         </p:nvSpPr>
@@ -20638,7 +22524,7 @@
       </p:sp>
       <p:sp>
         <p:nvSpPr>
-          <p:cNvPr id="16" name="TextBox 15"/>
+          <p:cNvPr id="18" name="TextBox 17"/>
           <p:cNvSpPr txBox="1"/>
           <p:nvPr/>
         </p:nvSpPr>
@@ -20672,7 +22558,7 @@
       </p:sp>
       <p:sp>
         <p:nvSpPr>
-          <p:cNvPr id="17" name="Oval 16"/>
+          <p:cNvPr id="19" name="Oval 18"/>
           <p:cNvSpPr/>
           <p:nvPr/>
         </p:nvSpPr>
@@ -20725,7 +22611,7 @@
       </p:sp>
       <p:sp>
         <p:nvSpPr>
-          <p:cNvPr id="18" name="TextBox 17"/>
+          <p:cNvPr id="20" name="TextBox 19"/>
           <p:cNvSpPr txBox="1"/>
           <p:nvPr/>
         </p:nvSpPr>
@@ -20759,7 +22645,7 @@
       </p:sp>
       <p:sp>
         <p:nvSpPr>
-          <p:cNvPr id="19" name="Oval 18"/>
+          <p:cNvPr id="21" name="Oval 20"/>
           <p:cNvSpPr/>
           <p:nvPr/>
         </p:nvSpPr>
@@ -20812,7 +22698,7 @@
       </p:sp>
       <p:sp>
         <p:nvSpPr>
-          <p:cNvPr id="20" name="TextBox 19"/>
+          <p:cNvPr id="22" name="TextBox 21"/>
           <p:cNvSpPr txBox="1"/>
           <p:nvPr/>
         </p:nvSpPr>
@@ -20846,7 +22732,7 @@
       </p:sp>
       <p:sp>
         <p:nvSpPr>
-          <p:cNvPr id="21" name="Oval 20"/>
+          <p:cNvPr id="23" name="Oval 22"/>
           <p:cNvSpPr/>
           <p:nvPr/>
         </p:nvSpPr>
@@ -20899,7 +22785,7 @@
       </p:sp>
       <p:sp>
         <p:nvSpPr>
-          <p:cNvPr id="22" name="TextBox 21"/>
+          <p:cNvPr id="24" name="TextBox 23"/>
           <p:cNvSpPr txBox="1"/>
           <p:nvPr/>
         </p:nvSpPr>
@@ -20933,7 +22819,7 @@
       </p:sp>
       <p:sp>
         <p:nvSpPr>
-          <p:cNvPr id="23" name="Oval 22"/>
+          <p:cNvPr id="25" name="Oval 24"/>
           <p:cNvSpPr/>
           <p:nvPr/>
         </p:nvSpPr>
@@ -20986,7 +22872,7 @@
       </p:sp>
       <p:sp>
         <p:nvSpPr>
-          <p:cNvPr id="24" name="TextBox 23"/>
+          <p:cNvPr id="26" name="TextBox 25"/>
           <p:cNvSpPr txBox="1"/>
           <p:nvPr/>
         </p:nvSpPr>
@@ -21020,7 +22906,7 @@
       </p:sp>
       <p:sp>
         <p:nvSpPr>
-          <p:cNvPr id="25" name="Oval 24"/>
+          <p:cNvPr id="27" name="Oval 26"/>
           <p:cNvSpPr/>
           <p:nvPr/>
         </p:nvSpPr>
@@ -21073,7 +22959,7 @@
       </p:sp>
       <p:sp>
         <p:nvSpPr>
-          <p:cNvPr id="26" name="TextBox 25"/>
+          <p:cNvPr id="28" name="TextBox 27"/>
           <p:cNvSpPr txBox="1"/>
           <p:nvPr/>
         </p:nvSpPr>
@@ -21107,7 +22993,7 @@
       </p:sp>
       <p:sp>
         <p:nvSpPr>
-          <p:cNvPr id="27" name="Oval 26"/>
+          <p:cNvPr id="29" name="Oval 28"/>
           <p:cNvSpPr/>
           <p:nvPr/>
         </p:nvSpPr>
@@ -21160,7 +23046,7 @@
       </p:sp>
       <p:sp>
         <p:nvSpPr>
-          <p:cNvPr id="28" name="TextBox 27"/>
+          <p:cNvPr id="30" name="TextBox 29"/>
           <p:cNvSpPr txBox="1"/>
           <p:nvPr/>
         </p:nvSpPr>
@@ -21575,14 +23461,177 @@
       </p:pic>
       <p:sp>
         <p:nvSpPr>
-          <p:cNvPr id="11" name="TextBox 10"/>
+          <p:cNvPr id="11" name="Rounded Rectangle 10"/>
+          <p:cNvSpPr/>
+          <p:nvPr/>
+        </p:nvSpPr>
+        <p:spPr>
+          <a:xfrm>
+            <a:off x="411479" y="1444752"/>
+            <a:ext cx="11368735" cy="4800600"/>
+          </a:xfrm>
+          <a:prstGeom prst="roundRect">
+            <a:avLst>
+              <a:gd name="adj" fmla="val 4000"/>
+            </a:avLst>
+          </a:prstGeom>
+          <a:solidFill>
+            <a:srgbClr val="FFFFFF">
+              <a:alpha val="84000"/>
+            </a:srgbClr>
+          </a:solidFill>
+          <a:ln w="19050">
+            <a:solidFill>
+              <a:srgbClr val="FFFFFF"/>
+            </a:solidFill>
+          </a:ln>
+          <a:effectLst>
+            <a:outerShdw blurRad="203200" dist="50800" dir="5400000" algn="t" rotWithShape="0">
+              <a:srgbClr val="1A2340">
+                <a:alpha val="20000"/>
+              </a:srgbClr>
+            </a:outerShdw>
+          </a:effectLst>
+        </p:spPr>
+        <p:style>
+          <a:lnRef idx="1">
+            <a:schemeClr val="accent1"/>
+          </a:lnRef>
+          <a:fillRef idx="3">
+            <a:schemeClr val="accent1"/>
+          </a:fillRef>
+          <a:effectRef idx="2">
+            <a:schemeClr val="accent1"/>
+          </a:effectRef>
+          <a:fontRef idx="minor">
+            <a:schemeClr val="lt1"/>
+          </a:fontRef>
+        </p:style>
+        <p:txBody>
+          <a:bodyPr rtlCol="0" anchor="ctr"/>
+          <a:lstStyle/>
+          <a:p>
+            <a:pPr algn="ctr"/>
+          </a:p>
+        </p:txBody>
+      </p:sp>
+      <p:sp>
+        <p:nvSpPr>
+          <p:cNvPr id="12" name="Rounded Rectangle 11"/>
+          <p:cNvSpPr/>
+          <p:nvPr/>
+        </p:nvSpPr>
+        <p:spPr>
+          <a:xfrm>
+            <a:off x="731519" y="1508760"/>
+            <a:ext cx="10728655" cy="32004"/>
+          </a:xfrm>
+          <a:prstGeom prst="roundRect">
+            <a:avLst>
+              <a:gd name="adj" fmla="val 50000"/>
+            </a:avLst>
+          </a:prstGeom>
+          <a:solidFill>
+            <a:srgbClr val="FFFFFF">
+              <a:alpha val="85000"/>
+            </a:srgbClr>
+          </a:solidFill>
+          <a:ln>
+            <a:noFill/>
+          </a:ln>
+          <a:effectLst/>
+        </p:spPr>
+        <p:style>
+          <a:lnRef idx="1">
+            <a:schemeClr val="accent1"/>
+          </a:lnRef>
+          <a:fillRef idx="3">
+            <a:schemeClr val="accent1"/>
+          </a:fillRef>
+          <a:effectRef idx="2">
+            <a:schemeClr val="accent1"/>
+          </a:effectRef>
+          <a:fontRef idx="minor">
+            <a:schemeClr val="lt1"/>
+          </a:fontRef>
+        </p:style>
+        <p:txBody>
+          <a:bodyPr rtlCol="0" anchor="ctr"/>
+          <a:lstStyle/>
+          <a:p>
+            <a:pPr algn="ctr"/>
+          </a:p>
+        </p:txBody>
+      </p:sp>
+      <p:sp>
+        <p:nvSpPr>
+          <p:cNvPr id="13" name="Rounded Rectangle 12"/>
+          <p:cNvSpPr/>
+          <p:nvPr/>
+        </p:nvSpPr>
+        <p:spPr>
+          <a:xfrm>
+            <a:off x="548640" y="1591056"/>
+            <a:ext cx="64008" cy="594360"/>
+          </a:xfrm>
+          <a:prstGeom prst="roundRect">
+            <a:avLst>
+              <a:gd name="adj" fmla="val 50000"/>
+            </a:avLst>
+          </a:prstGeom>
+          <a:solidFill>
+            <a:srgbClr val="8D6A2A"/>
+          </a:solidFill>
+          <a:ln>
+            <a:noFill/>
+          </a:ln>
+          <a:effectLst>
+            <a:outerShdw blurRad="203200" dist="50800" dir="5400000" algn="t" rotWithShape="0">
+              <a:srgbClr val="1A2340">
+                <a:alpha val="20000"/>
+              </a:srgbClr>
+            </a:outerShdw>
+          </a:effectLst>
+          <a:scene3d>
+            <a:camera prst="orthographicFront"/>
+            <a:lightRig rig="threePt" dir="t"/>
+          </a:scene3d>
+          <a:sp3d>
+            <a:bevelT w="44450" h="25400" prst="softRound"/>
+          </a:sp3d>
+        </p:spPr>
+        <p:style>
+          <a:lnRef idx="1">
+            <a:schemeClr val="accent1"/>
+          </a:lnRef>
+          <a:fillRef idx="3">
+            <a:schemeClr val="accent1"/>
+          </a:fillRef>
+          <a:effectRef idx="2">
+            <a:schemeClr val="accent1"/>
+          </a:effectRef>
+          <a:fontRef idx="minor">
+            <a:schemeClr val="lt1"/>
+          </a:fontRef>
+        </p:style>
+        <p:txBody>
+          <a:bodyPr rtlCol="0" anchor="ctr"/>
+          <a:lstStyle/>
+          <a:p>
+            <a:pPr algn="ctr"/>
+          </a:p>
+        </p:txBody>
+      </p:sp>
+      <p:sp>
+        <p:nvSpPr>
+          <p:cNvPr id="14" name="TextBox 13"/>
           <p:cNvSpPr txBox="1"/>
           <p:nvPr/>
         </p:nvSpPr>
         <p:spPr>
           <a:xfrm>
-            <a:off x="548640" y="1554480"/>
-            <a:ext cx="11094415" cy="795528"/>
+            <a:off x="777240" y="1554480"/>
+            <a:ext cx="10865815" cy="795528"/>
           </a:xfrm>
           <a:prstGeom prst="rect">
             <a:avLst/>
@@ -21614,7 +23663,7 @@
       </p:sp>
       <p:sp>
         <p:nvSpPr>
-          <p:cNvPr id="12" name="Oval 11"/>
+          <p:cNvPr id="15" name="Oval 14"/>
           <p:cNvSpPr/>
           <p:nvPr/>
         </p:nvSpPr>
@@ -21667,7 +23716,7 @@
       </p:sp>
       <p:sp>
         <p:nvSpPr>
-          <p:cNvPr id="13" name="TextBox 12"/>
+          <p:cNvPr id="16" name="TextBox 15"/>
           <p:cNvSpPr txBox="1"/>
           <p:nvPr/>
         </p:nvSpPr>
@@ -21710,7 +23759,7 @@
       </p:sp>
       <p:sp>
         <p:nvSpPr>
-          <p:cNvPr id="14" name="Oval 13"/>
+          <p:cNvPr id="17" name="Oval 16"/>
           <p:cNvSpPr/>
           <p:nvPr/>
         </p:nvSpPr>
@@ -21763,7 +23812,7 @@
       </p:sp>
       <p:sp>
         <p:nvSpPr>
-          <p:cNvPr id="15" name="TextBox 14"/>
+          <p:cNvPr id="18" name="TextBox 17"/>
           <p:cNvSpPr txBox="1"/>
           <p:nvPr/>
         </p:nvSpPr>
@@ -21806,7 +23855,7 @@
       </p:sp>
       <p:sp>
         <p:nvSpPr>
-          <p:cNvPr id="16" name="Oval 15"/>
+          <p:cNvPr id="19" name="Oval 18"/>
           <p:cNvSpPr/>
           <p:nvPr/>
         </p:nvSpPr>
@@ -21859,7 +23908,7 @@
       </p:sp>
       <p:sp>
         <p:nvSpPr>
-          <p:cNvPr id="17" name="TextBox 16"/>
+          <p:cNvPr id="20" name="TextBox 19"/>
           <p:cNvSpPr txBox="1"/>
           <p:nvPr/>
         </p:nvSpPr>
@@ -22283,14 +24332,177 @@
       </p:pic>
       <p:sp>
         <p:nvSpPr>
-          <p:cNvPr id="11" name="TextBox 10"/>
+          <p:cNvPr id="11" name="Rounded Rectangle 10"/>
+          <p:cNvSpPr/>
+          <p:nvPr/>
+        </p:nvSpPr>
+        <p:spPr>
+          <a:xfrm>
+            <a:off x="411479" y="1444752"/>
+            <a:ext cx="11368735" cy="4800600"/>
+          </a:xfrm>
+          <a:prstGeom prst="roundRect">
+            <a:avLst>
+              <a:gd name="adj" fmla="val 4000"/>
+            </a:avLst>
+          </a:prstGeom>
+          <a:solidFill>
+            <a:srgbClr val="FFFFFF">
+              <a:alpha val="84000"/>
+            </a:srgbClr>
+          </a:solidFill>
+          <a:ln w="19050">
+            <a:solidFill>
+              <a:srgbClr val="FFFFFF"/>
+            </a:solidFill>
+          </a:ln>
+          <a:effectLst>
+            <a:outerShdw blurRad="203200" dist="50800" dir="5400000" algn="t" rotWithShape="0">
+              <a:srgbClr val="1A2340">
+                <a:alpha val="20000"/>
+              </a:srgbClr>
+            </a:outerShdw>
+          </a:effectLst>
+        </p:spPr>
+        <p:style>
+          <a:lnRef idx="1">
+            <a:schemeClr val="accent1"/>
+          </a:lnRef>
+          <a:fillRef idx="3">
+            <a:schemeClr val="accent1"/>
+          </a:fillRef>
+          <a:effectRef idx="2">
+            <a:schemeClr val="accent1"/>
+          </a:effectRef>
+          <a:fontRef idx="minor">
+            <a:schemeClr val="lt1"/>
+          </a:fontRef>
+        </p:style>
+        <p:txBody>
+          <a:bodyPr rtlCol="0" anchor="ctr"/>
+          <a:lstStyle/>
+          <a:p>
+            <a:pPr algn="ctr"/>
+          </a:p>
+        </p:txBody>
+      </p:sp>
+      <p:sp>
+        <p:nvSpPr>
+          <p:cNvPr id="12" name="Rounded Rectangle 11"/>
+          <p:cNvSpPr/>
+          <p:nvPr/>
+        </p:nvSpPr>
+        <p:spPr>
+          <a:xfrm>
+            <a:off x="731519" y="1508760"/>
+            <a:ext cx="10728655" cy="32004"/>
+          </a:xfrm>
+          <a:prstGeom prst="roundRect">
+            <a:avLst>
+              <a:gd name="adj" fmla="val 50000"/>
+            </a:avLst>
+          </a:prstGeom>
+          <a:solidFill>
+            <a:srgbClr val="FFFFFF">
+              <a:alpha val="85000"/>
+            </a:srgbClr>
+          </a:solidFill>
+          <a:ln>
+            <a:noFill/>
+          </a:ln>
+          <a:effectLst/>
+        </p:spPr>
+        <p:style>
+          <a:lnRef idx="1">
+            <a:schemeClr val="accent1"/>
+          </a:lnRef>
+          <a:fillRef idx="3">
+            <a:schemeClr val="accent1"/>
+          </a:fillRef>
+          <a:effectRef idx="2">
+            <a:schemeClr val="accent1"/>
+          </a:effectRef>
+          <a:fontRef idx="minor">
+            <a:schemeClr val="lt1"/>
+          </a:fontRef>
+        </p:style>
+        <p:txBody>
+          <a:bodyPr rtlCol="0" anchor="ctr"/>
+          <a:lstStyle/>
+          <a:p>
+            <a:pPr algn="ctr"/>
+          </a:p>
+        </p:txBody>
+      </p:sp>
+      <p:sp>
+        <p:nvSpPr>
+          <p:cNvPr id="13" name="Rounded Rectangle 12"/>
+          <p:cNvSpPr/>
+          <p:nvPr/>
+        </p:nvSpPr>
+        <p:spPr>
+          <a:xfrm>
+            <a:off x="548640" y="1591056"/>
+            <a:ext cx="64008" cy="315468"/>
+          </a:xfrm>
+          <a:prstGeom prst="roundRect">
+            <a:avLst>
+              <a:gd name="adj" fmla="val 50000"/>
+            </a:avLst>
+          </a:prstGeom>
+          <a:solidFill>
+            <a:srgbClr val="8D6A2A"/>
+          </a:solidFill>
+          <a:ln>
+            <a:noFill/>
+          </a:ln>
+          <a:effectLst>
+            <a:outerShdw blurRad="203200" dist="50800" dir="5400000" algn="t" rotWithShape="0">
+              <a:srgbClr val="1A2340">
+                <a:alpha val="20000"/>
+              </a:srgbClr>
+            </a:outerShdw>
+          </a:effectLst>
+          <a:scene3d>
+            <a:camera prst="orthographicFront"/>
+            <a:lightRig rig="threePt" dir="t"/>
+          </a:scene3d>
+          <a:sp3d>
+            <a:bevelT w="44450" h="25400" prst="softRound"/>
+          </a:sp3d>
+        </p:spPr>
+        <p:style>
+          <a:lnRef idx="1">
+            <a:schemeClr val="accent1"/>
+          </a:lnRef>
+          <a:fillRef idx="3">
+            <a:schemeClr val="accent1"/>
+          </a:fillRef>
+          <a:effectRef idx="2">
+            <a:schemeClr val="accent1"/>
+          </a:effectRef>
+          <a:fontRef idx="minor">
+            <a:schemeClr val="lt1"/>
+          </a:fontRef>
+        </p:style>
+        <p:txBody>
+          <a:bodyPr rtlCol="0" anchor="ctr"/>
+          <a:lstStyle/>
+          <a:p>
+            <a:pPr algn="ctr"/>
+          </a:p>
+        </p:txBody>
+      </p:sp>
+      <p:sp>
+        <p:nvSpPr>
+          <p:cNvPr id="14" name="TextBox 13"/>
           <p:cNvSpPr txBox="1"/>
           <p:nvPr/>
         </p:nvSpPr>
         <p:spPr>
           <a:xfrm>
-            <a:off x="548640" y="1554480"/>
-            <a:ext cx="11094415" cy="498348"/>
+            <a:off x="777240" y="1554480"/>
+            <a:ext cx="10865815" cy="498348"/>
           </a:xfrm>
           <a:prstGeom prst="rect">
             <a:avLst/>
@@ -22322,7 +24534,7 @@
       </p:sp>
       <p:graphicFrame>
         <p:nvGraphicFramePr>
-          <p:cNvPr id="12" name="Table 11"/>
+          <p:cNvPr id="15" name="Table 14"/>
           <p:cNvGraphicFramePr>
             <a:graphicFrameLocks noGrp="1"/>
           </p:cNvGraphicFramePr>
@@ -23068,9 +25280,167 @@
           </a:prstGeom>
         </p:spPr>
       </p:pic>
+      <p:sp>
+        <p:nvSpPr>
+          <p:cNvPr id="11" name="Rounded Rectangle 10"/>
+          <p:cNvSpPr/>
+          <p:nvPr/>
+        </p:nvSpPr>
+        <p:spPr>
+          <a:xfrm>
+            <a:off x="411479" y="1444752"/>
+            <a:ext cx="11368735" cy="4800600"/>
+          </a:xfrm>
+          <a:prstGeom prst="roundRect">
+            <a:avLst>
+              <a:gd name="adj" fmla="val 4000"/>
+            </a:avLst>
+          </a:prstGeom>
+          <a:solidFill>
+            <a:srgbClr val="FFFFFF">
+              <a:alpha val="84000"/>
+            </a:srgbClr>
+          </a:solidFill>
+          <a:ln w="19050">
+            <a:solidFill>
+              <a:srgbClr val="FFFFFF"/>
+            </a:solidFill>
+          </a:ln>
+          <a:effectLst>
+            <a:outerShdw blurRad="203200" dist="50800" dir="5400000" algn="t" rotWithShape="0">
+              <a:srgbClr val="1A2340">
+                <a:alpha val="20000"/>
+              </a:srgbClr>
+            </a:outerShdw>
+          </a:effectLst>
+        </p:spPr>
+        <p:style>
+          <a:lnRef idx="1">
+            <a:schemeClr val="accent1"/>
+          </a:lnRef>
+          <a:fillRef idx="3">
+            <a:schemeClr val="accent1"/>
+          </a:fillRef>
+          <a:effectRef idx="2">
+            <a:schemeClr val="accent1"/>
+          </a:effectRef>
+          <a:fontRef idx="minor">
+            <a:schemeClr val="lt1"/>
+          </a:fontRef>
+        </p:style>
+        <p:txBody>
+          <a:bodyPr rtlCol="0" anchor="ctr"/>
+          <a:lstStyle/>
+          <a:p>
+            <a:pPr algn="ctr"/>
+          </a:p>
+        </p:txBody>
+      </p:sp>
+      <p:sp>
+        <p:nvSpPr>
+          <p:cNvPr id="12" name="Rounded Rectangle 11"/>
+          <p:cNvSpPr/>
+          <p:nvPr/>
+        </p:nvSpPr>
+        <p:spPr>
+          <a:xfrm>
+            <a:off x="731519" y="1508760"/>
+            <a:ext cx="10728655" cy="32004"/>
+          </a:xfrm>
+          <a:prstGeom prst="roundRect">
+            <a:avLst>
+              <a:gd name="adj" fmla="val 50000"/>
+            </a:avLst>
+          </a:prstGeom>
+          <a:solidFill>
+            <a:srgbClr val="FFFFFF">
+              <a:alpha val="85000"/>
+            </a:srgbClr>
+          </a:solidFill>
+          <a:ln>
+            <a:noFill/>
+          </a:ln>
+          <a:effectLst/>
+        </p:spPr>
+        <p:style>
+          <a:lnRef idx="1">
+            <a:schemeClr val="accent1"/>
+          </a:lnRef>
+          <a:fillRef idx="3">
+            <a:schemeClr val="accent1"/>
+          </a:fillRef>
+          <a:effectRef idx="2">
+            <a:schemeClr val="accent1"/>
+          </a:effectRef>
+          <a:fontRef idx="minor">
+            <a:schemeClr val="lt1"/>
+          </a:fontRef>
+        </p:style>
+        <p:txBody>
+          <a:bodyPr rtlCol="0" anchor="ctr"/>
+          <a:lstStyle/>
+          <a:p>
+            <a:pPr algn="ctr"/>
+          </a:p>
+        </p:txBody>
+      </p:sp>
+      <p:sp>
+        <p:nvSpPr>
+          <p:cNvPr id="13" name="Rounded Rectangle 12"/>
+          <p:cNvSpPr/>
+          <p:nvPr/>
+        </p:nvSpPr>
+        <p:spPr>
+          <a:xfrm>
+            <a:off x="548640" y="1554480"/>
+            <a:ext cx="11094415" cy="4617720"/>
+          </a:xfrm>
+          <a:prstGeom prst="roundRect">
+            <a:avLst>
+              <a:gd name="adj" fmla="val 3000"/>
+            </a:avLst>
+          </a:prstGeom>
+          <a:solidFill>
+            <a:srgbClr val="FFFFFF"/>
+          </a:solidFill>
+          <a:ln w="9525">
+            <a:solidFill>
+              <a:srgbClr val="DDDFEE"/>
+            </a:solidFill>
+          </a:ln>
+          <a:effectLst>
+            <a:outerShdw blurRad="203200" dist="50800" dir="5400000" algn="t" rotWithShape="0">
+              <a:srgbClr val="1A2340">
+                <a:alpha val="20000"/>
+              </a:srgbClr>
+            </a:outerShdw>
+          </a:effectLst>
+        </p:spPr>
+        <p:style>
+          <a:lnRef idx="1">
+            <a:schemeClr val="accent1"/>
+          </a:lnRef>
+          <a:fillRef idx="3">
+            <a:schemeClr val="accent1"/>
+          </a:fillRef>
+          <a:effectRef idx="2">
+            <a:schemeClr val="accent1"/>
+          </a:effectRef>
+          <a:fontRef idx="minor">
+            <a:schemeClr val="lt1"/>
+          </a:fontRef>
+        </p:style>
+        <p:txBody>
+          <a:bodyPr rtlCol="0" anchor="ctr"/>
+          <a:lstStyle/>
+          <a:p>
+            <a:pPr algn="ctr"/>
+          </a:p>
+        </p:txBody>
+      </p:sp>
       <p:pic>
         <p:nvPicPr>
-          <p:cNvPr id="11" name="Picture 10" descr="Two panels. Left: acetylcholine released into the synapse is broken down by acetylcholinesterase, which donepezil blocks. Right: excess glutamate over-activates NMDA receptors; memantine blocks the open channel."/>
+          <p:cNvPr id="14" name="Picture 13" descr="Two panels. Left: acetylcholine released into the synapse is broken down by acetylcholinesterase, which donepezil blocks. Right: excess glutamate over-activates NMDA receptors; memantine blocks the open channel."/>
           <p:cNvPicPr>
             <a:picLocks noChangeAspect="1"/>
           </p:cNvPicPr>
@@ -23084,8 +25454,8 @@
         </p:blipFill>
         <p:spPr>
           <a:xfrm>
-            <a:off x="1638917" y="1554480"/>
-            <a:ext cx="8913860" cy="4160520"/>
+            <a:off x="1834828" y="1664207"/>
+            <a:ext cx="8522039" cy="3977639"/>
           </a:xfrm>
           <a:prstGeom prst="rect">
             <a:avLst/>
@@ -23094,14 +25464,14 @@
       </p:pic>
       <p:sp>
         <p:nvSpPr>
-          <p:cNvPr id="12" name="TextBox 11"/>
+          <p:cNvPr id="15" name="TextBox 14"/>
           <p:cNvSpPr txBox="1"/>
           <p:nvPr/>
         </p:nvSpPr>
         <p:spPr>
           <a:xfrm>
-            <a:off x="548640" y="5806440"/>
-            <a:ext cx="11094415" cy="365760"/>
+            <a:off x="685800" y="5733287"/>
+            <a:ext cx="10820095" cy="365760"/>
           </a:xfrm>
           <a:prstGeom prst="rect">
             <a:avLst/>
@@ -23177,6 +25547,110 @@
           </a:prstGeom>
         </p:spPr>
       </p:pic>
+      <p:sp>
+        <p:nvSpPr>
+          <p:cNvPr id="10" name="Rounded Rectangle 9"/>
+          <p:cNvSpPr/>
+          <p:nvPr/>
+        </p:nvSpPr>
+        <p:spPr>
+          <a:xfrm>
+            <a:off x="4251960" y="548640"/>
+            <a:ext cx="7635240" cy="5715000"/>
+          </a:xfrm>
+          <a:prstGeom prst="roundRect">
+            <a:avLst>
+              <a:gd name="adj" fmla="val 4000"/>
+            </a:avLst>
+          </a:prstGeom>
+          <a:solidFill>
+            <a:srgbClr val="FFFFFF">
+              <a:alpha val="84000"/>
+            </a:srgbClr>
+          </a:solidFill>
+          <a:ln w="19050">
+            <a:solidFill>
+              <a:srgbClr val="FFFFFF"/>
+            </a:solidFill>
+          </a:ln>
+          <a:effectLst>
+            <a:outerShdw blurRad="203200" dist="50800" dir="5400000" algn="t" rotWithShape="0">
+              <a:srgbClr val="1A2340">
+                <a:alpha val="20000"/>
+              </a:srgbClr>
+            </a:outerShdw>
+          </a:effectLst>
+        </p:spPr>
+        <p:style>
+          <a:lnRef idx="1">
+            <a:schemeClr val="accent1"/>
+          </a:lnRef>
+          <a:fillRef idx="3">
+            <a:schemeClr val="accent1"/>
+          </a:fillRef>
+          <a:effectRef idx="2">
+            <a:schemeClr val="accent1"/>
+          </a:effectRef>
+          <a:fontRef idx="minor">
+            <a:schemeClr val="lt1"/>
+          </a:fontRef>
+        </p:style>
+        <p:txBody>
+          <a:bodyPr rtlCol="0" anchor="ctr"/>
+          <a:lstStyle/>
+          <a:p>
+            <a:pPr algn="ctr"/>
+          </a:p>
+        </p:txBody>
+      </p:sp>
+      <p:sp>
+        <p:nvSpPr>
+          <p:cNvPr id="11" name="Rounded Rectangle 10"/>
+          <p:cNvSpPr/>
+          <p:nvPr/>
+        </p:nvSpPr>
+        <p:spPr>
+          <a:xfrm>
+            <a:off x="4572000" y="612647"/>
+            <a:ext cx="6995159" cy="32004"/>
+          </a:xfrm>
+          <a:prstGeom prst="roundRect">
+            <a:avLst>
+              <a:gd name="adj" fmla="val 50000"/>
+            </a:avLst>
+          </a:prstGeom>
+          <a:solidFill>
+            <a:srgbClr val="FFFFFF">
+              <a:alpha val="85000"/>
+            </a:srgbClr>
+          </a:solidFill>
+          <a:ln>
+            <a:noFill/>
+          </a:ln>
+          <a:effectLst/>
+        </p:spPr>
+        <p:style>
+          <a:lnRef idx="1">
+            <a:schemeClr val="accent1"/>
+          </a:lnRef>
+          <a:fillRef idx="3">
+            <a:schemeClr val="accent1"/>
+          </a:fillRef>
+          <a:effectRef idx="2">
+            <a:schemeClr val="accent1"/>
+          </a:effectRef>
+          <a:fontRef idx="minor">
+            <a:schemeClr val="lt1"/>
+          </a:fontRef>
+        </p:style>
+        <p:txBody>
+          <a:bodyPr rtlCol="0" anchor="ctr"/>
+          <a:lstStyle/>
+          <a:p>
+            <a:pPr algn="ctr"/>
+          </a:p>
+        </p:txBody>
+      </p:sp>
       <p:sp>
         <p:nvSpPr>
           <p:cNvPr id="3" name="Rectangle 2"/>
@@ -23815,14 +26289,177 @@
       </p:pic>
       <p:sp>
         <p:nvSpPr>
-          <p:cNvPr id="11" name="TextBox 10"/>
+          <p:cNvPr id="11" name="Rounded Rectangle 10"/>
+          <p:cNvSpPr/>
+          <p:nvPr/>
+        </p:nvSpPr>
+        <p:spPr>
+          <a:xfrm>
+            <a:off x="411479" y="1444752"/>
+            <a:ext cx="11368735" cy="4800600"/>
+          </a:xfrm>
+          <a:prstGeom prst="roundRect">
+            <a:avLst>
+              <a:gd name="adj" fmla="val 4000"/>
+            </a:avLst>
+          </a:prstGeom>
+          <a:solidFill>
+            <a:srgbClr val="FFFFFF">
+              <a:alpha val="84000"/>
+            </a:srgbClr>
+          </a:solidFill>
+          <a:ln w="19050">
+            <a:solidFill>
+              <a:srgbClr val="FFFFFF"/>
+            </a:solidFill>
+          </a:ln>
+          <a:effectLst>
+            <a:outerShdw blurRad="203200" dist="50800" dir="5400000" algn="t" rotWithShape="0">
+              <a:srgbClr val="1A2340">
+                <a:alpha val="20000"/>
+              </a:srgbClr>
+            </a:outerShdw>
+          </a:effectLst>
+        </p:spPr>
+        <p:style>
+          <a:lnRef idx="1">
+            <a:schemeClr val="accent1"/>
+          </a:lnRef>
+          <a:fillRef idx="3">
+            <a:schemeClr val="accent1"/>
+          </a:fillRef>
+          <a:effectRef idx="2">
+            <a:schemeClr val="accent1"/>
+          </a:effectRef>
+          <a:fontRef idx="minor">
+            <a:schemeClr val="lt1"/>
+          </a:fontRef>
+        </p:style>
+        <p:txBody>
+          <a:bodyPr rtlCol="0" anchor="ctr"/>
+          <a:lstStyle/>
+          <a:p>
+            <a:pPr algn="ctr"/>
+          </a:p>
+        </p:txBody>
+      </p:sp>
+      <p:sp>
+        <p:nvSpPr>
+          <p:cNvPr id="12" name="Rounded Rectangle 11"/>
+          <p:cNvSpPr/>
+          <p:nvPr/>
+        </p:nvSpPr>
+        <p:spPr>
+          <a:xfrm>
+            <a:off x="731519" y="1508760"/>
+            <a:ext cx="10728655" cy="32004"/>
+          </a:xfrm>
+          <a:prstGeom prst="roundRect">
+            <a:avLst>
+              <a:gd name="adj" fmla="val 50000"/>
+            </a:avLst>
+          </a:prstGeom>
+          <a:solidFill>
+            <a:srgbClr val="FFFFFF">
+              <a:alpha val="85000"/>
+            </a:srgbClr>
+          </a:solidFill>
+          <a:ln>
+            <a:noFill/>
+          </a:ln>
+          <a:effectLst/>
+        </p:spPr>
+        <p:style>
+          <a:lnRef idx="1">
+            <a:schemeClr val="accent1"/>
+          </a:lnRef>
+          <a:fillRef idx="3">
+            <a:schemeClr val="accent1"/>
+          </a:fillRef>
+          <a:effectRef idx="2">
+            <a:schemeClr val="accent1"/>
+          </a:effectRef>
+          <a:fontRef idx="minor">
+            <a:schemeClr val="lt1"/>
+          </a:fontRef>
+        </p:style>
+        <p:txBody>
+          <a:bodyPr rtlCol="0" anchor="ctr"/>
+          <a:lstStyle/>
+          <a:p>
+            <a:pPr algn="ctr"/>
+          </a:p>
+        </p:txBody>
+      </p:sp>
+      <p:sp>
+        <p:nvSpPr>
+          <p:cNvPr id="13" name="Rounded Rectangle 12"/>
+          <p:cNvSpPr/>
+          <p:nvPr/>
+        </p:nvSpPr>
+        <p:spPr>
+          <a:xfrm>
+            <a:off x="548640" y="1591056"/>
+            <a:ext cx="64008" cy="3489959"/>
+          </a:xfrm>
+          <a:prstGeom prst="roundRect">
+            <a:avLst>
+              <a:gd name="adj" fmla="val 50000"/>
+            </a:avLst>
+          </a:prstGeom>
+          <a:solidFill>
+            <a:srgbClr val="8D6A2A"/>
+          </a:solidFill>
+          <a:ln>
+            <a:noFill/>
+          </a:ln>
+          <a:effectLst>
+            <a:outerShdw blurRad="203200" dist="50800" dir="5400000" algn="t" rotWithShape="0">
+              <a:srgbClr val="1A2340">
+                <a:alpha val="20000"/>
+              </a:srgbClr>
+            </a:outerShdw>
+          </a:effectLst>
+          <a:scene3d>
+            <a:camera prst="orthographicFront"/>
+            <a:lightRig rig="threePt" dir="t"/>
+          </a:scene3d>
+          <a:sp3d>
+            <a:bevelT w="44450" h="25400" prst="softRound"/>
+          </a:sp3d>
+        </p:spPr>
+        <p:style>
+          <a:lnRef idx="1">
+            <a:schemeClr val="accent1"/>
+          </a:lnRef>
+          <a:fillRef idx="3">
+            <a:schemeClr val="accent1"/>
+          </a:fillRef>
+          <a:effectRef idx="2">
+            <a:schemeClr val="accent1"/>
+          </a:effectRef>
+          <a:fontRef idx="minor">
+            <a:schemeClr val="lt1"/>
+          </a:fontRef>
+        </p:style>
+        <p:txBody>
+          <a:bodyPr rtlCol="0" anchor="ctr"/>
+          <a:lstStyle/>
+          <a:p>
+            <a:pPr algn="ctr"/>
+          </a:p>
+        </p:txBody>
+      </p:sp>
+      <p:sp>
+        <p:nvSpPr>
+          <p:cNvPr id="14" name="TextBox 13"/>
           <p:cNvSpPr txBox="1"/>
           <p:nvPr/>
         </p:nvSpPr>
         <p:spPr>
           <a:xfrm>
-            <a:off x="548640" y="1554480"/>
-            <a:ext cx="4480560" cy="4617720"/>
+            <a:off x="777240" y="1554480"/>
+            <a:ext cx="4251960" cy="4617720"/>
           </a:xfrm>
           <a:prstGeom prst="rect">
             <a:avLst/>
@@ -23904,7 +26541,7 @@
       </p:sp>
       <p:sp>
         <p:nvSpPr>
-          <p:cNvPr id="12" name="Oval 11"/>
+          <p:cNvPr id="15" name="Oval 14"/>
           <p:cNvSpPr/>
           <p:nvPr/>
         </p:nvSpPr>
@@ -23957,7 +26594,7 @@
       </p:sp>
       <p:sp>
         <p:nvSpPr>
-          <p:cNvPr id="13" name="TextBox 12"/>
+          <p:cNvPr id="16" name="TextBox 15"/>
           <p:cNvSpPr txBox="1"/>
           <p:nvPr/>
         </p:nvSpPr>
@@ -24000,7 +26637,7 @@
       </p:sp>
       <p:sp>
         <p:nvSpPr>
-          <p:cNvPr id="14" name="Oval 13"/>
+          <p:cNvPr id="17" name="Oval 16"/>
           <p:cNvSpPr/>
           <p:nvPr/>
         </p:nvSpPr>
@@ -24053,7 +26690,7 @@
       </p:sp>
       <p:sp>
         <p:nvSpPr>
-          <p:cNvPr id="15" name="TextBox 14"/>
+          <p:cNvPr id="18" name="TextBox 17"/>
           <p:cNvSpPr txBox="1"/>
           <p:nvPr/>
         </p:nvSpPr>
@@ -24144,6 +26781,110 @@
           </a:prstGeom>
         </p:spPr>
       </p:pic>
+      <p:sp>
+        <p:nvSpPr>
+          <p:cNvPr id="10" name="Rounded Rectangle 9"/>
+          <p:cNvSpPr/>
+          <p:nvPr/>
+        </p:nvSpPr>
+        <p:spPr>
+          <a:xfrm>
+            <a:off x="4251960" y="548640"/>
+            <a:ext cx="7635240" cy="5715000"/>
+          </a:xfrm>
+          <a:prstGeom prst="roundRect">
+            <a:avLst>
+              <a:gd name="adj" fmla="val 4000"/>
+            </a:avLst>
+          </a:prstGeom>
+          <a:solidFill>
+            <a:srgbClr val="FFFFFF">
+              <a:alpha val="84000"/>
+            </a:srgbClr>
+          </a:solidFill>
+          <a:ln w="19050">
+            <a:solidFill>
+              <a:srgbClr val="FFFFFF"/>
+            </a:solidFill>
+          </a:ln>
+          <a:effectLst>
+            <a:outerShdw blurRad="203200" dist="50800" dir="5400000" algn="t" rotWithShape="0">
+              <a:srgbClr val="1A2340">
+                <a:alpha val="20000"/>
+              </a:srgbClr>
+            </a:outerShdw>
+          </a:effectLst>
+        </p:spPr>
+        <p:style>
+          <a:lnRef idx="1">
+            <a:schemeClr val="accent1"/>
+          </a:lnRef>
+          <a:fillRef idx="3">
+            <a:schemeClr val="accent1"/>
+          </a:fillRef>
+          <a:effectRef idx="2">
+            <a:schemeClr val="accent1"/>
+          </a:effectRef>
+          <a:fontRef idx="minor">
+            <a:schemeClr val="lt1"/>
+          </a:fontRef>
+        </p:style>
+        <p:txBody>
+          <a:bodyPr rtlCol="0" anchor="ctr"/>
+          <a:lstStyle/>
+          <a:p>
+            <a:pPr algn="ctr"/>
+          </a:p>
+        </p:txBody>
+      </p:sp>
+      <p:sp>
+        <p:nvSpPr>
+          <p:cNvPr id="11" name="Rounded Rectangle 10"/>
+          <p:cNvSpPr/>
+          <p:nvPr/>
+        </p:nvSpPr>
+        <p:spPr>
+          <a:xfrm>
+            <a:off x="4572000" y="612647"/>
+            <a:ext cx="6995159" cy="32004"/>
+          </a:xfrm>
+          <a:prstGeom prst="roundRect">
+            <a:avLst>
+              <a:gd name="adj" fmla="val 50000"/>
+            </a:avLst>
+          </a:prstGeom>
+          <a:solidFill>
+            <a:srgbClr val="FFFFFF">
+              <a:alpha val="85000"/>
+            </a:srgbClr>
+          </a:solidFill>
+          <a:ln>
+            <a:noFill/>
+          </a:ln>
+          <a:effectLst/>
+        </p:spPr>
+        <p:style>
+          <a:lnRef idx="1">
+            <a:schemeClr val="accent1"/>
+          </a:lnRef>
+          <a:fillRef idx="3">
+            <a:schemeClr val="accent1"/>
+          </a:fillRef>
+          <a:effectRef idx="2">
+            <a:schemeClr val="accent1"/>
+          </a:effectRef>
+          <a:fontRef idx="minor">
+            <a:schemeClr val="lt1"/>
+          </a:fontRef>
+        </p:style>
+        <p:txBody>
+          <a:bodyPr rtlCol="0" anchor="ctr"/>
+          <a:lstStyle/>
+          <a:p>
+            <a:pPr algn="ctr"/>
+          </a:p>
+        </p:txBody>
+      </p:sp>
       <p:sp>
         <p:nvSpPr>
           <p:cNvPr id="3" name="Rectangle 2"/>

</xml_diff>